<commit_message>
Strengthen merge verification and refresh judged artifacts
</commit_message>
<xml_diff>
--- a/submission/mergewitness-deck-final-v2.pptx
+++ b/submission/mergewitness-deck-final-v2.pptx
@@ -2,18 +2,18 @@
 <file path=ppt/presentation.xml><?xml version="1.0" encoding="utf-8"?>
 <p:presentation xmlns:p="http://schemas.openxmlformats.org/presentationml/2006/main">
   <p:sldMasterIdLst>
-    <p:sldMasterId xmlns:r="http://schemas.openxmlformats.org/officeDocument/2006/relationships" id="2147483648" r:id="Re4541df20cea4857"/>
+    <p:sldMasterId xmlns:r="http://schemas.openxmlformats.org/officeDocument/2006/relationships" id="2147483648" r:id="Rca202581058e48ab"/>
   </p:sldMasterIdLst>
   <p:notesMasterIdLst>
-    <p:notesMasterId xmlns:r="http://schemas.openxmlformats.org/officeDocument/2006/relationships" r:id="R62d7dba40fff43d8"/>
+    <p:notesMasterId xmlns:r="http://schemas.openxmlformats.org/officeDocument/2006/relationships" r:id="R019d941ed0424cef"/>
   </p:notesMasterIdLst>
   <p:sldIdLst>
-    <p:sldId xmlns:r="http://schemas.openxmlformats.org/officeDocument/2006/relationships" id="256" r:id="R4a868d299660497c"/>
-    <p:sldId xmlns:r="http://schemas.openxmlformats.org/officeDocument/2006/relationships" id="257" r:id="R8aa93af7f875473a"/>
-    <p:sldId xmlns:r="http://schemas.openxmlformats.org/officeDocument/2006/relationships" id="258" r:id="R01da2fff2f4941f3"/>
-    <p:sldId xmlns:r="http://schemas.openxmlformats.org/officeDocument/2006/relationships" id="259" r:id="R83ab1ace3e2e476d"/>
-    <p:sldId xmlns:r="http://schemas.openxmlformats.org/officeDocument/2006/relationships" id="260" r:id="R2358b28ff92d4870"/>
-    <p:sldId xmlns:r="http://schemas.openxmlformats.org/officeDocument/2006/relationships" id="261" r:id="R51d356f7f1b04b65"/>
+    <p:sldId xmlns:r="http://schemas.openxmlformats.org/officeDocument/2006/relationships" id="256" r:id="R9e27569321984a64"/>
+    <p:sldId xmlns:r="http://schemas.openxmlformats.org/officeDocument/2006/relationships" id="257" r:id="Ra9fd953f355d498b"/>
+    <p:sldId xmlns:r="http://schemas.openxmlformats.org/officeDocument/2006/relationships" id="258" r:id="R276d53aeafe6425e"/>
+    <p:sldId xmlns:r="http://schemas.openxmlformats.org/officeDocument/2006/relationships" id="259" r:id="R2f1b71832ff94905"/>
+    <p:sldId xmlns:r="http://schemas.openxmlformats.org/officeDocument/2006/relationships" id="260" r:id="R60fbecaee4d14afc"/>
+    <p:sldId xmlns:r="http://schemas.openxmlformats.org/officeDocument/2006/relationships" id="261" r:id="R0b70f85f0c7d4618"/>
   </p:sldIdLst>
   <p:sldSz cx="12192000" cy="6858000"/>
   <p:notesSz cx="6858000" cy="9144000"/>
@@ -657,7 +657,7 @@
           <a:lstStyle xmlns:a="http://schemas.openxmlformats.org/drawingml/2006/main"/>
           <a:p xmlns:a="http://schemas.openxmlformats.org/drawingml/2006/main">
             <a:r>
-              <a:t>Task 1: fad890dd4396030a3cdd86588dbbf59f, 0.953 Bobcoins. Task 2: d09305949f41fdff62b67e8e966d6c74, 0.637 Bobcoins. Both screenshots are recorded in bob_sessions/.</a:t>
+              <a:t>Task 1: fad890dd4396030a3cdd86588dbbf59f, 0.953 Bobcoins; Bob wrote the original tenant-cache probe. Task 2: d09305949f41fdff62b67e8e966d6c74, 0.637 Bobcoins; Bob wrote the tenant-cache repair. Task 3: 4901e274fb4230386d1463da9b82ce4f, 0.552 Bobcoins; Bob wrote the priority-cursor probe and two feature checks. Independent report reports/priority-cursor-evaluation.public.json records Base, A and B pass 3/3 and combined fail 3/3. Screenshots: bob_sessions/01-tenant-cache-probe-summary.png, 02-tenant-cache-repair-summary.png and 03-priority-cursor-probe-summary.png. No repair is claimed for the priority-cursor fixture.</a:t>
             </a:r>
           </a:p>
         </p:txBody>
@@ -797,7 +797,7 @@
           <a:lstStyle xmlns:a="http://schemas.openxmlformats.org/drawingml/2006/main"/>
           <a:p xmlns:a="http://schemas.openxmlformats.org/drawingml/2006/main">
             <a:r>
-              <a:t>Positioning reflects related work: QuietClash, SAM and test-based semantic conflict research, plus merge queues. Cite final public links in the README and submission after they are verified.</a:t>
+              <a:t>Live demo: https://lawliet8886.github.io/MergeWitness/ . Code, Bob task evidence and public reports: https://github.com/lawliet8886/MergeWitness . A passing probe establishes only the tested behavior, not universal merge safety.</a:t>
             </a:r>
           </a:p>
         </p:txBody>
@@ -865,7 +865,7 @@
   </p:cSld>
   <p:clrMap bg1="lt1" tx1="dk1" bg2="lt2" tx2="dk2" accent1="accent1" accent2="accent2" accent3="accent3" accent4="accent4" accent5="accent5" accent6="accent6" hlink="hlink" folHlink="folHlink"/>
   <p:sldLayoutIdLst>
-    <p:sldLayoutId xmlns:r="http://schemas.openxmlformats.org/officeDocument/2006/relationships" id="2147483649" r:id="R10944143d94744cc"/>
+    <p:sldLayoutId xmlns:r="http://schemas.openxmlformats.org/officeDocument/2006/relationships" id="2147483649" r:id="R542745baea044327"/>
   </p:sldLayoutIdLst>
   <p:txStyles>
     <p:titleStyle>
@@ -1413,10 +1413,10 @@
       </p:grpSpPr>
       <p:sp>
         <p:nvSpPr>
-          <p:cNvPr id="14" name="">
-            <a:extLst xmlns:a="http://schemas.openxmlformats.org/drawingml/2006/main">
-              <a:ext uri="{FF2B5EF4-FFF2-40B4-BE49-F238E27FC236}">
-                <a16:creationId xmlns:a16="http://schemas.microsoft.com/office/drawing/2014/main" id="{9B259935-EAC7-4FDB-9540-9BE30A84051C}"/>
+          <p:cNvPr id="18" name="">
+            <a:extLst xmlns:a="http://schemas.openxmlformats.org/drawingml/2006/main">
+              <a:ext uri="{FF2B5EF4-FFF2-40B4-BE49-F238E27FC236}">
+                <a16:creationId xmlns:a16="http://schemas.microsoft.com/office/drawing/2014/main" id="{3936D725-8731-4389-BA24-4C7B089B9B2F}"/>
               </a:ext>
             </a:extLst>
           </p:cNvPr>
@@ -1446,7 +1446,7 @@
           <p:cNvPr id="2" name="">
             <a:extLst xmlns:a="http://schemas.openxmlformats.org/drawingml/2006/main">
               <a:ext uri="{FF2B5EF4-FFF2-40B4-BE49-F238E27FC236}">
-                <a16:creationId xmlns:a16="http://schemas.microsoft.com/office/drawing/2014/main" id="{9E8C4CC2-A3D9-43FD-A6B5-43CC421FB063}"/>
+                <a16:creationId xmlns:a16="http://schemas.microsoft.com/office/drawing/2014/main" id="{BB38C05B-B778-44AA-8357-2D3219BD61E5}"/>
               </a:ext>
             </a:extLst>
           </p:cNvPr>
@@ -1503,7 +1503,7 @@
           <p:cNvPr id="3" name="">
             <a:extLst xmlns:a="http://schemas.openxmlformats.org/drawingml/2006/main">
               <a:ext uri="{FF2B5EF4-FFF2-40B4-BE49-F238E27FC236}">
-                <a16:creationId xmlns:a16="http://schemas.microsoft.com/office/drawing/2014/main" id="{104D9DC6-82D0-47E8-B1DA-ABA43DFCE616}"/>
+                <a16:creationId xmlns:a16="http://schemas.microsoft.com/office/drawing/2014/main" id="{086C89A6-9948-422B-A2D3-BD85D9E63207}"/>
               </a:ext>
             </a:extLst>
           </p:cNvPr>
@@ -1560,7 +1560,7 @@
           <p:cNvPr id="4" name="">
             <a:extLst xmlns:a="http://schemas.openxmlformats.org/drawingml/2006/main">
               <a:ext uri="{FF2B5EF4-FFF2-40B4-BE49-F238E27FC236}">
-                <a16:creationId xmlns:a16="http://schemas.microsoft.com/office/drawing/2014/main" id="{C5C39D6B-B35A-4B0E-83A0-17903B9A25A5}"/>
+                <a16:creationId xmlns:a16="http://schemas.microsoft.com/office/drawing/2014/main" id="{500DD60E-5CAB-4AF7-B407-0A581BC72CE9}"/>
               </a:ext>
             </a:extLst>
           </p:cNvPr>
@@ -1617,23 +1617,271 @@
           <p:cNvPr id="5" name="">
             <a:extLst xmlns:a="http://schemas.openxmlformats.org/drawingml/2006/main">
               <a:ext uri="{FF2B5EF4-FFF2-40B4-BE49-F238E27FC236}">
-                <a16:creationId xmlns:a16="http://schemas.microsoft.com/office/drawing/2014/main" id="{A473B8CB-A7F9-4CA2-9CFE-756B30639A7D}"/>
-              </a:ext>
-            </a:extLst>
-          </p:cNvPr>
-          <p:cNvSpPr>
-            <a:spLocks xmlns:a="http://schemas.openxmlformats.org/drawingml/2006/main" noGrp="1"/>
-          </p:cNvSpPr>
-          <p:nvPr/>
-        </p:nvSpPr>
-        <p:spPr>
-          <a:xfrm xmlns:a="http://schemas.openxmlformats.org/drawingml/2006/main">
-            <a:off x="7620000" y="1600200"/>
-            <a:ext cx="1047750" cy="571500"/>
+                <a16:creationId xmlns:a16="http://schemas.microsoft.com/office/drawing/2014/main" id="{760E98A9-8B7F-475A-BCD7-985F06BCDA9A}"/>
+              </a:ext>
+            </a:extLst>
+          </p:cNvPr>
+          <p:cNvSpPr>
+            <a:spLocks xmlns:a="http://schemas.openxmlformats.org/drawingml/2006/main" noGrp="1"/>
+          </p:cNvSpPr>
+          <p:nvPr/>
+        </p:nvSpPr>
+        <p:spPr>
+          <a:xfrm xmlns:a="http://schemas.openxmlformats.org/drawingml/2006/main">
+            <a:off x="9505950" y="1543050"/>
+            <a:ext cx="0" cy="476250"/>
+          </a:xfrm>
+          <a:prstGeom xmlns:a="http://schemas.openxmlformats.org/drawingml/2006/main" prst="line">
+            <a:avLst/>
+          </a:prstGeom>
+          <a:noFill xmlns:a="http://schemas.openxmlformats.org/drawingml/2006/main"/>
+          <a:ln xmlns:a="http://schemas.openxmlformats.org/drawingml/2006/main" w="28575">
+            <a:solidFill>
+              <a:srgbClr val="315476"/>
+            </a:solidFill>
+            <a:prstDash val="solid"/>
+          </a:ln>
+        </p:spPr>
+      </p:sp>
+      <p:sp>
+        <p:nvSpPr>
+          <p:cNvPr id="6" name="">
+            <a:extLst xmlns:a="http://schemas.openxmlformats.org/drawingml/2006/main">
+              <a:ext uri="{FF2B5EF4-FFF2-40B4-BE49-F238E27FC236}">
+                <a16:creationId xmlns:a16="http://schemas.microsoft.com/office/drawing/2014/main" id="{129D9E4F-FD8E-4F79-ABBE-F45183293DC8}"/>
+              </a:ext>
+            </a:extLst>
+          </p:cNvPr>
+          <p:cNvSpPr>
+            <a:spLocks xmlns:a="http://schemas.openxmlformats.org/drawingml/2006/main" noGrp="1"/>
+          </p:cNvSpPr>
+          <p:nvPr/>
+        </p:nvSpPr>
+        <p:spPr>
+          <a:xfrm xmlns:a="http://schemas.openxmlformats.org/drawingml/2006/main">
+            <a:off x="8267700" y="2019300"/>
+            <a:ext cx="2419350" cy="0"/>
+          </a:xfrm>
+          <a:prstGeom xmlns:a="http://schemas.openxmlformats.org/drawingml/2006/main" prst="line">
+            <a:avLst/>
+          </a:prstGeom>
+          <a:noFill xmlns:a="http://schemas.openxmlformats.org/drawingml/2006/main"/>
+          <a:ln xmlns:a="http://schemas.openxmlformats.org/drawingml/2006/main" w="28575">
+            <a:solidFill>
+              <a:srgbClr val="315476"/>
+            </a:solidFill>
+            <a:prstDash val="solid"/>
+          </a:ln>
+        </p:spPr>
+      </p:sp>
+      <p:sp>
+        <p:nvSpPr>
+          <p:cNvPr id="7" name="">
+            <a:extLst xmlns:a="http://schemas.openxmlformats.org/drawingml/2006/main">
+              <a:ext uri="{FF2B5EF4-FFF2-40B4-BE49-F238E27FC236}">
+                <a16:creationId xmlns:a16="http://schemas.microsoft.com/office/drawing/2014/main" id="{0F223018-BB51-436A-83B1-9EE348EEB56C}"/>
+              </a:ext>
+            </a:extLst>
+          </p:cNvPr>
+          <p:cNvSpPr>
+            <a:spLocks xmlns:a="http://schemas.openxmlformats.org/drawingml/2006/main" noGrp="1"/>
+          </p:cNvSpPr>
+          <p:nvPr/>
+        </p:nvSpPr>
+        <p:spPr>
+          <a:xfrm xmlns:a="http://schemas.openxmlformats.org/drawingml/2006/main">
+            <a:off x="8267700" y="2019300"/>
+            <a:ext cx="0" cy="457200"/>
+          </a:xfrm>
+          <a:prstGeom xmlns:a="http://schemas.openxmlformats.org/drawingml/2006/main" prst="line">
+            <a:avLst/>
+          </a:prstGeom>
+          <a:noFill xmlns:a="http://schemas.openxmlformats.org/drawingml/2006/main"/>
+          <a:ln xmlns:a="http://schemas.openxmlformats.org/drawingml/2006/main" w="28575">
+            <a:solidFill>
+              <a:srgbClr val="315476"/>
+            </a:solidFill>
+            <a:prstDash val="solid"/>
+          </a:ln>
+        </p:spPr>
+      </p:sp>
+      <p:sp>
+        <p:nvSpPr>
+          <p:cNvPr id="8" name="">
+            <a:extLst xmlns:a="http://schemas.openxmlformats.org/drawingml/2006/main">
+              <a:ext uri="{FF2B5EF4-FFF2-40B4-BE49-F238E27FC236}">
+                <a16:creationId xmlns:a16="http://schemas.microsoft.com/office/drawing/2014/main" id="{87526824-54B7-4D61-B59D-BDBFD03366E7}"/>
+              </a:ext>
+            </a:extLst>
+          </p:cNvPr>
+          <p:cNvSpPr>
+            <a:spLocks xmlns:a="http://schemas.openxmlformats.org/drawingml/2006/main" noGrp="1"/>
+          </p:cNvSpPr>
+          <p:nvPr/>
+        </p:nvSpPr>
+        <p:spPr>
+          <a:xfrm xmlns:a="http://schemas.openxmlformats.org/drawingml/2006/main">
+            <a:off x="10687050" y="2019300"/>
+            <a:ext cx="0" cy="457200"/>
+          </a:xfrm>
+          <a:prstGeom xmlns:a="http://schemas.openxmlformats.org/drawingml/2006/main" prst="line">
+            <a:avLst/>
+          </a:prstGeom>
+          <a:noFill xmlns:a="http://schemas.openxmlformats.org/drawingml/2006/main"/>
+          <a:ln xmlns:a="http://schemas.openxmlformats.org/drawingml/2006/main" w="28575">
+            <a:solidFill>
+              <a:srgbClr val="315476"/>
+            </a:solidFill>
+            <a:prstDash val="solid"/>
+          </a:ln>
+        </p:spPr>
+      </p:sp>
+      <p:sp>
+        <p:nvSpPr>
+          <p:cNvPr id="9" name="">
+            <a:extLst xmlns:a="http://schemas.openxmlformats.org/drawingml/2006/main">
+              <a:ext uri="{FF2B5EF4-FFF2-40B4-BE49-F238E27FC236}">
+                <a16:creationId xmlns:a16="http://schemas.microsoft.com/office/drawing/2014/main" id="{783006A2-B851-48C4-80ED-8445433865DE}"/>
+              </a:ext>
+            </a:extLst>
+          </p:cNvPr>
+          <p:cNvSpPr>
+            <a:spLocks xmlns:a="http://schemas.openxmlformats.org/drawingml/2006/main" noGrp="1"/>
+          </p:cNvSpPr>
+          <p:nvPr/>
+        </p:nvSpPr>
+        <p:spPr>
+          <a:xfrm xmlns:a="http://schemas.openxmlformats.org/drawingml/2006/main">
+            <a:off x="8267700" y="3143250"/>
+            <a:ext cx="0" cy="476250"/>
+          </a:xfrm>
+          <a:prstGeom xmlns:a="http://schemas.openxmlformats.org/drawingml/2006/main" prst="line">
+            <a:avLst/>
+          </a:prstGeom>
+          <a:noFill xmlns:a="http://schemas.openxmlformats.org/drawingml/2006/main"/>
+          <a:ln xmlns:a="http://schemas.openxmlformats.org/drawingml/2006/main" w="28575">
+            <a:solidFill>
+              <a:srgbClr val="315476"/>
+            </a:solidFill>
+            <a:prstDash val="solid"/>
+          </a:ln>
+        </p:spPr>
+      </p:sp>
+      <p:sp>
+        <p:nvSpPr>
+          <p:cNvPr id="10" name="">
+            <a:extLst xmlns:a="http://schemas.openxmlformats.org/drawingml/2006/main">
+              <a:ext uri="{FF2B5EF4-FFF2-40B4-BE49-F238E27FC236}">
+                <a16:creationId xmlns:a16="http://schemas.microsoft.com/office/drawing/2014/main" id="{BAC684F8-1BA9-4268-AB97-0861AE91A03A}"/>
+              </a:ext>
+            </a:extLst>
+          </p:cNvPr>
+          <p:cNvSpPr>
+            <a:spLocks xmlns:a="http://schemas.openxmlformats.org/drawingml/2006/main" noGrp="1"/>
+          </p:cNvSpPr>
+          <p:nvPr/>
+        </p:nvSpPr>
+        <p:spPr>
+          <a:xfrm xmlns:a="http://schemas.openxmlformats.org/drawingml/2006/main">
+            <a:off x="10687050" y="3143250"/>
+            <a:ext cx="0" cy="476250"/>
+          </a:xfrm>
+          <a:prstGeom xmlns:a="http://schemas.openxmlformats.org/drawingml/2006/main" prst="line">
+            <a:avLst/>
+          </a:prstGeom>
+          <a:noFill xmlns:a="http://schemas.openxmlformats.org/drawingml/2006/main"/>
+          <a:ln xmlns:a="http://schemas.openxmlformats.org/drawingml/2006/main" w="28575">
+            <a:solidFill>
+              <a:srgbClr val="315476"/>
+            </a:solidFill>
+            <a:prstDash val="solid"/>
+          </a:ln>
+        </p:spPr>
+      </p:sp>
+      <p:sp>
+        <p:nvSpPr>
+          <p:cNvPr id="11" name="">
+            <a:extLst xmlns:a="http://schemas.openxmlformats.org/drawingml/2006/main">
+              <a:ext uri="{FF2B5EF4-FFF2-40B4-BE49-F238E27FC236}">
+                <a16:creationId xmlns:a16="http://schemas.microsoft.com/office/drawing/2014/main" id="{7FCB47A6-01C6-40E3-87EE-8654D9A99832}"/>
+              </a:ext>
+            </a:extLst>
+          </p:cNvPr>
+          <p:cNvSpPr>
+            <a:spLocks xmlns:a="http://schemas.openxmlformats.org/drawingml/2006/main" noGrp="1"/>
+          </p:cNvSpPr>
+          <p:nvPr/>
+        </p:nvSpPr>
+        <p:spPr>
+          <a:xfrm xmlns:a="http://schemas.openxmlformats.org/drawingml/2006/main">
+            <a:off x="8267700" y="3619500"/>
+            <a:ext cx="2419350" cy="0"/>
+          </a:xfrm>
+          <a:prstGeom xmlns:a="http://schemas.openxmlformats.org/drawingml/2006/main" prst="line">
+            <a:avLst/>
+          </a:prstGeom>
+          <a:noFill xmlns:a="http://schemas.openxmlformats.org/drawingml/2006/main"/>
+          <a:ln xmlns:a="http://schemas.openxmlformats.org/drawingml/2006/main" w="28575">
+            <a:solidFill>
+              <a:srgbClr val="315476"/>
+            </a:solidFill>
+            <a:prstDash val="solid"/>
+          </a:ln>
+        </p:spPr>
+      </p:sp>
+      <p:sp>
+        <p:nvSpPr>
+          <p:cNvPr id="12" name="">
+            <a:extLst xmlns:a="http://schemas.openxmlformats.org/drawingml/2006/main">
+              <a:ext uri="{FF2B5EF4-FFF2-40B4-BE49-F238E27FC236}">
+                <a16:creationId xmlns:a16="http://schemas.microsoft.com/office/drawing/2014/main" id="{CA2A7BBD-93CE-4537-8E98-2B2E2A7DAD3D}"/>
+              </a:ext>
+            </a:extLst>
+          </p:cNvPr>
+          <p:cNvSpPr>
+            <a:spLocks xmlns:a="http://schemas.openxmlformats.org/drawingml/2006/main" noGrp="1"/>
+          </p:cNvSpPr>
+          <p:nvPr/>
+        </p:nvSpPr>
+        <p:spPr>
+          <a:xfrm xmlns:a="http://schemas.openxmlformats.org/drawingml/2006/main">
+            <a:off x="9505950" y="3619500"/>
+            <a:ext cx="0" cy="323850"/>
+          </a:xfrm>
+          <a:prstGeom xmlns:a="http://schemas.openxmlformats.org/drawingml/2006/main" prst="line">
+            <a:avLst/>
+          </a:prstGeom>
+          <a:noFill xmlns:a="http://schemas.openxmlformats.org/drawingml/2006/main"/>
+          <a:ln xmlns:a="http://schemas.openxmlformats.org/drawingml/2006/main" w="28575">
+            <a:solidFill>
+              <a:srgbClr val="315476"/>
+            </a:solidFill>
+            <a:prstDash val="solid"/>
+          </a:ln>
+        </p:spPr>
+      </p:sp>
+      <p:sp>
+        <p:nvSpPr>
+          <p:cNvPr id="13" name="">
+            <a:extLst xmlns:a="http://schemas.openxmlformats.org/drawingml/2006/main">
+              <a:ext uri="{FF2B5EF4-FFF2-40B4-BE49-F238E27FC236}">
+                <a16:creationId xmlns:a16="http://schemas.microsoft.com/office/drawing/2014/main" id="{201653ED-1DEB-4F88-8E03-2DD79E5F79BD}"/>
+              </a:ext>
+            </a:extLst>
+          </p:cNvPr>
+          <p:cNvSpPr>
+            <a:spLocks xmlns:a="http://schemas.openxmlformats.org/drawingml/2006/main" noGrp="1"/>
+          </p:cNvSpPr>
+          <p:nvPr/>
+        </p:nvSpPr>
+        <p:spPr>
+          <a:xfrm xmlns:a="http://schemas.openxmlformats.org/drawingml/2006/main">
+            <a:off x="8839200" y="942975"/>
+            <a:ext cx="1333500" cy="600075"/>
           </a:xfrm>
           <a:prstGeom xmlns:a="http://schemas.openxmlformats.org/drawingml/2006/main" prst="roundRect">
             <a:avLst>
-              <a:gd name="adj" fmla="val 23333"/>
+              <a:gd name="adj" fmla="val 22222"/>
             </a:avLst>
           </a:prstGeom>
           <a:solidFill xmlns:a="http://schemas.openxmlformats.org/drawingml/2006/main">
@@ -1678,22 +1926,22 @@
       </p:sp>
       <p:sp>
         <p:nvSpPr>
-          <p:cNvPr id="6" name="">
-            <a:extLst xmlns:a="http://schemas.openxmlformats.org/drawingml/2006/main">
-              <a:ext uri="{FF2B5EF4-FFF2-40B4-BE49-F238E27FC236}">
-                <a16:creationId xmlns:a16="http://schemas.microsoft.com/office/drawing/2014/main" id="{CD4E74E8-8AF6-4E08-9B80-3044264B90A1}"/>
-              </a:ext>
-            </a:extLst>
-          </p:cNvPr>
-          <p:cNvSpPr>
-            <a:spLocks xmlns:a="http://schemas.openxmlformats.org/drawingml/2006/main" noGrp="1"/>
-          </p:cNvSpPr>
-          <p:nvPr/>
-        </p:nvSpPr>
-        <p:spPr>
-          <a:xfrm xmlns:a="http://schemas.openxmlformats.org/drawingml/2006/main">
-            <a:off x="9239250" y="857250"/>
-            <a:ext cx="1619250" cy="666750"/>
+          <p:cNvPr id="14" name="">
+            <a:extLst xmlns:a="http://schemas.openxmlformats.org/drawingml/2006/main">
+              <a:ext uri="{FF2B5EF4-FFF2-40B4-BE49-F238E27FC236}">
+                <a16:creationId xmlns:a16="http://schemas.microsoft.com/office/drawing/2014/main" id="{9CAD3C5C-84AE-49C3-B829-E6D4E56D793E}"/>
+              </a:ext>
+            </a:extLst>
+          </p:cNvPr>
+          <p:cNvSpPr>
+            <a:spLocks xmlns:a="http://schemas.openxmlformats.org/drawingml/2006/main" noGrp="1"/>
+          </p:cNvSpPr>
+          <p:nvPr/>
+        </p:nvSpPr>
+        <p:spPr>
+          <a:xfrm xmlns:a="http://schemas.openxmlformats.org/drawingml/2006/main">
+            <a:off x="7429500" y="2476500"/>
+            <a:ext cx="1676400" cy="666750"/>
           </a:xfrm>
           <a:prstGeom xmlns:a="http://schemas.openxmlformats.org/drawingml/2006/main" prst="roundRect">
             <a:avLst>
@@ -1765,22 +2013,22 @@
       </p:sp>
       <p:sp>
         <p:nvSpPr>
-          <p:cNvPr id="7" name="">
-            <a:extLst xmlns:a="http://schemas.openxmlformats.org/drawingml/2006/main">
-              <a:ext uri="{FF2B5EF4-FFF2-40B4-BE49-F238E27FC236}">
-                <a16:creationId xmlns:a16="http://schemas.microsoft.com/office/drawing/2014/main" id="{AE96E2DB-7BBF-431D-8677-417A9D6E215B}"/>
-              </a:ext>
-            </a:extLst>
-          </p:cNvPr>
-          <p:cNvSpPr>
-            <a:spLocks xmlns:a="http://schemas.openxmlformats.org/drawingml/2006/main" noGrp="1"/>
-          </p:cNvSpPr>
-          <p:nvPr/>
-        </p:nvSpPr>
-        <p:spPr>
-          <a:xfrm xmlns:a="http://schemas.openxmlformats.org/drawingml/2006/main">
-            <a:off x="9239250" y="2381250"/>
-            <a:ext cx="1619250" cy="666750"/>
+          <p:cNvPr id="15" name="">
+            <a:extLst xmlns:a="http://schemas.openxmlformats.org/drawingml/2006/main">
+              <a:ext uri="{FF2B5EF4-FFF2-40B4-BE49-F238E27FC236}">
+                <a16:creationId xmlns:a16="http://schemas.microsoft.com/office/drawing/2014/main" id="{9C4010AF-71FD-40A8-B203-D60393F4D3E6}"/>
+              </a:ext>
+            </a:extLst>
+          </p:cNvPr>
+          <p:cNvSpPr>
+            <a:spLocks xmlns:a="http://schemas.openxmlformats.org/drawingml/2006/main" noGrp="1"/>
+          </p:cNvSpPr>
+          <p:nvPr/>
+        </p:nvSpPr>
+        <p:spPr>
+          <a:xfrm xmlns:a="http://schemas.openxmlformats.org/drawingml/2006/main">
+            <a:off x="9848850" y="2476500"/>
+            <a:ext cx="1676400" cy="666750"/>
           </a:xfrm>
           <a:prstGeom xmlns:a="http://schemas.openxmlformats.org/drawingml/2006/main" prst="roundRect">
             <a:avLst>
@@ -1852,22 +2100,22 @@
       </p:sp>
       <p:sp>
         <p:nvSpPr>
-          <p:cNvPr id="8" name="">
-            <a:extLst xmlns:a="http://schemas.openxmlformats.org/drawingml/2006/main">
-              <a:ext uri="{FF2B5EF4-FFF2-40B4-BE49-F238E27FC236}">
-                <a16:creationId xmlns:a16="http://schemas.microsoft.com/office/drawing/2014/main" id="{F54252F9-A03E-45B0-AAE6-9189F863C7BF}"/>
-              </a:ext>
-            </a:extLst>
-          </p:cNvPr>
-          <p:cNvSpPr>
-            <a:spLocks xmlns:a="http://schemas.openxmlformats.org/drawingml/2006/main" noGrp="1"/>
-          </p:cNvSpPr>
-          <p:nvPr/>
-        </p:nvSpPr>
-        <p:spPr>
-          <a:xfrm xmlns:a="http://schemas.openxmlformats.org/drawingml/2006/main">
-            <a:off x="7620000" y="3667125"/>
-            <a:ext cx="2000250" cy="723900"/>
+          <p:cNvPr id="16" name="">
+            <a:extLst xmlns:a="http://schemas.openxmlformats.org/drawingml/2006/main">
+              <a:ext uri="{FF2B5EF4-FFF2-40B4-BE49-F238E27FC236}">
+                <a16:creationId xmlns:a16="http://schemas.microsoft.com/office/drawing/2014/main" id="{177F0732-EF6A-4049-9F5F-47AAFF466F1F}"/>
+              </a:ext>
+            </a:extLst>
+          </p:cNvPr>
+          <p:cNvSpPr>
+            <a:spLocks xmlns:a="http://schemas.openxmlformats.org/drawingml/2006/main" noGrp="1"/>
+          </p:cNvSpPr>
+          <p:nvPr/>
+        </p:nvSpPr>
+        <p:spPr>
+          <a:xfrm xmlns:a="http://schemas.openxmlformats.org/drawingml/2006/main">
+            <a:off x="8543925" y="3943350"/>
+            <a:ext cx="1924050" cy="723900"/>
           </a:xfrm>
           <a:prstGeom xmlns:a="http://schemas.openxmlformats.org/drawingml/2006/main" prst="roundRect">
             <a:avLst>
@@ -1937,126 +2185,12 @@
           </a:p>
         </p:txBody>
       </p:sp>
-      <p:cxnSp>
-        <p:nvCxnSpPr>
-          <p:cNvPr id="22" name=""/>
-          <p:cNvCxnSpPr>
-            <a:stCxn xmlns:a="http://schemas.openxmlformats.org/drawingml/2006/main" id="6" idx="2"/>
-            <a:endCxn xmlns:a="http://schemas.openxmlformats.org/drawingml/2006/main" id="8" idx="0"/>
-          </p:cNvCxnSpPr>
-          <p:nvPr/>
-        </p:nvCxnSpPr>
-        <p:spPr>
-          <a:xfrm xmlns:a="http://schemas.openxmlformats.org/drawingml/2006/main" flipH="1">
-            <a:off x="8620125" y="1524000"/>
-            <a:ext cx="1428750" cy="2143125"/>
-          </a:xfrm>
-          <a:prstGeom xmlns:a="http://schemas.openxmlformats.org/drawingml/2006/main" prst="straightConnector1">
-            <a:avLst/>
-          </a:prstGeom>
-          <a:ln xmlns:a="http://schemas.openxmlformats.org/drawingml/2006/main" w="19050">
-            <a:solidFill>
-              <a:srgbClr val="315476"/>
-            </a:solidFill>
-            <a:prstDash val="solid"/>
-            <a:headEnd type="arrow" w="sm" len="sm"/>
-          </a:ln>
-        </p:spPr>
-      </p:cxnSp>
-      <p:cxnSp>
-        <p:nvCxnSpPr>
-          <p:cNvPr id="23" name=""/>
-          <p:cNvCxnSpPr>
-            <a:stCxn xmlns:a="http://schemas.openxmlformats.org/drawingml/2006/main" id="7" idx="2"/>
-            <a:endCxn xmlns:a="http://schemas.openxmlformats.org/drawingml/2006/main" id="8" idx="3"/>
-          </p:cNvCxnSpPr>
-          <p:nvPr/>
-        </p:nvCxnSpPr>
-        <p:spPr>
-          <a:xfrm xmlns:a="http://schemas.openxmlformats.org/drawingml/2006/main" flipH="1">
-            <a:off x="9620250" y="3048000"/>
-            <a:ext cx="428625" cy="981075"/>
-          </a:xfrm>
-          <a:prstGeom xmlns:a="http://schemas.openxmlformats.org/drawingml/2006/main" prst="straightConnector1">
-            <a:avLst/>
-          </a:prstGeom>
-          <a:ln xmlns:a="http://schemas.openxmlformats.org/drawingml/2006/main" w="19050">
-            <a:solidFill>
-              <a:srgbClr val="315476"/>
-            </a:solidFill>
-            <a:prstDash val="solid"/>
-            <a:headEnd type="arrow" w="sm" len="sm"/>
-          </a:ln>
-        </p:spPr>
-      </p:cxnSp>
-      <p:sp>
-        <p:nvSpPr>
-          <p:cNvPr id="11" name="">
-            <a:extLst xmlns:a="http://schemas.openxmlformats.org/drawingml/2006/main">
-              <a:ext uri="{FF2B5EF4-FFF2-40B4-BE49-F238E27FC236}">
-                <a16:creationId xmlns:a16="http://schemas.microsoft.com/office/drawing/2014/main" id="{82DD7D47-59A8-4924-8944-909977831563}"/>
-              </a:ext>
-            </a:extLst>
-          </p:cNvPr>
-          <p:cNvSpPr>
-            <a:spLocks xmlns:a="http://schemas.openxmlformats.org/drawingml/2006/main" noGrp="1"/>
-          </p:cNvSpPr>
-          <p:nvPr/>
-        </p:nvSpPr>
-        <p:spPr>
-          <a:xfrm xmlns:a="http://schemas.openxmlformats.org/drawingml/2006/main">
-            <a:off x="8667750" y="1190625"/>
-            <a:ext cx="571500" cy="981075"/>
-          </a:xfrm>
-          <a:prstGeom xmlns:a="http://schemas.openxmlformats.org/drawingml/2006/main" prst="line">
-            <a:avLst/>
-          </a:prstGeom>
-          <a:noFill xmlns:a="http://schemas.openxmlformats.org/drawingml/2006/main"/>
-          <a:ln xmlns:a="http://schemas.openxmlformats.org/drawingml/2006/main" w="19050">
-            <a:solidFill>
-              <a:srgbClr val="315476"/>
-            </a:solidFill>
-            <a:prstDash val="solid"/>
-          </a:ln>
-        </p:spPr>
-      </p:sp>
-      <p:sp>
-        <p:nvSpPr>
-          <p:cNvPr id="12" name="">
-            <a:extLst xmlns:a="http://schemas.openxmlformats.org/drawingml/2006/main">
-              <a:ext uri="{FF2B5EF4-FFF2-40B4-BE49-F238E27FC236}">
-                <a16:creationId xmlns:a16="http://schemas.microsoft.com/office/drawing/2014/main" id="{1F7756EC-AE5D-4501-B13D-6F02F5F47E7E}"/>
-              </a:ext>
-            </a:extLst>
-          </p:cNvPr>
-          <p:cNvSpPr>
-            <a:spLocks xmlns:a="http://schemas.openxmlformats.org/drawingml/2006/main" noGrp="1"/>
-          </p:cNvSpPr>
-          <p:nvPr/>
-        </p:nvSpPr>
-        <p:spPr>
-          <a:xfrm xmlns:a="http://schemas.openxmlformats.org/drawingml/2006/main">
-            <a:off x="8667750" y="2171700"/>
-            <a:ext cx="571500" cy="542925"/>
-          </a:xfrm>
-          <a:prstGeom xmlns:a="http://schemas.openxmlformats.org/drawingml/2006/main" prst="line">
-            <a:avLst/>
-          </a:prstGeom>
-          <a:noFill xmlns:a="http://schemas.openxmlformats.org/drawingml/2006/main"/>
-          <a:ln xmlns:a="http://schemas.openxmlformats.org/drawingml/2006/main" w="19050">
-            <a:solidFill>
-              <a:srgbClr val="315476"/>
-            </a:solidFill>
-            <a:prstDash val="solid"/>
-          </a:ln>
-        </p:spPr>
-      </p:sp>
-      <p:sp>
-        <p:nvSpPr>
-          <p:cNvPr id="13" name="">
-            <a:extLst xmlns:a="http://schemas.openxmlformats.org/drawingml/2006/main">
-              <a:ext uri="{FF2B5EF4-FFF2-40B4-BE49-F238E27FC236}">
-                <a16:creationId xmlns:a16="http://schemas.microsoft.com/office/drawing/2014/main" id="{400B66A8-8BC8-4380-AE78-83CA990C14BA}"/>
+      <p:sp>
+        <p:nvSpPr>
+          <p:cNvPr id="17" name="">
+            <a:extLst xmlns:a="http://schemas.openxmlformats.org/drawingml/2006/main">
+              <a:ext uri="{FF2B5EF4-FFF2-40B4-BE49-F238E27FC236}">
+                <a16:creationId xmlns:a16="http://schemas.microsoft.com/office/drawing/2014/main" id="{2E906DF9-A842-412E-B80D-8DC3B7475E8D}"/>
               </a:ext>
             </a:extLst>
           </p:cNvPr>
@@ -2134,7 +2268,7 @@
     </p:spTree>
     <p:extLst>
       <p:ext uri="{BB962C8B-B14F-4D97-AF65-F5344CB8AC3E}">
-        <p14:creationId xmlns:p14="http://schemas.microsoft.com/office/powerpoint/2010/main" val="281884870"/>
+        <p14:creationId xmlns:p14="http://schemas.microsoft.com/office/powerpoint/2010/main" val="2040122394"/>
       </p:ext>
     </p:extLst>
   </p:cSld>
@@ -2162,10 +2296,10 @@
       </p:grpSpPr>
       <p:sp>
         <p:nvSpPr>
-          <p:cNvPr id="13" name="">
-            <a:extLst xmlns:a="http://schemas.openxmlformats.org/drawingml/2006/main">
-              <a:ext uri="{FF2B5EF4-FFF2-40B4-BE49-F238E27FC236}">
-                <a16:creationId xmlns:a16="http://schemas.microsoft.com/office/drawing/2014/main" id="{5E31C3DB-58C9-4D3B-ACEC-0CF8F937E452}"/>
+          <p:cNvPr id="21" name="">
+            <a:extLst xmlns:a="http://schemas.openxmlformats.org/drawingml/2006/main">
+              <a:ext uri="{FF2B5EF4-FFF2-40B4-BE49-F238E27FC236}">
+                <a16:creationId xmlns:a16="http://schemas.microsoft.com/office/drawing/2014/main" id="{9EA92373-7BDB-49DC-B9AB-C2673EBFD58A}"/>
               </a:ext>
             </a:extLst>
           </p:cNvPr>
@@ -2195,7 +2329,7 @@
           <p:cNvPr id="2" name="">
             <a:extLst xmlns:a="http://schemas.openxmlformats.org/drawingml/2006/main">
               <a:ext uri="{FF2B5EF4-FFF2-40B4-BE49-F238E27FC236}">
-                <a16:creationId xmlns:a16="http://schemas.microsoft.com/office/drawing/2014/main" id="{C484AC02-79A4-4A2B-8E82-2331316D36FF}"/>
+                <a16:creationId xmlns:a16="http://schemas.microsoft.com/office/drawing/2014/main" id="{EDA19AF9-966D-4F0C-8282-99DEE84D00E4}"/>
               </a:ext>
             </a:extLst>
           </p:cNvPr>
@@ -2252,7 +2386,7 @@
           <p:cNvPr id="3" name="">
             <a:extLst xmlns:a="http://schemas.openxmlformats.org/drawingml/2006/main">
               <a:ext uri="{FF2B5EF4-FFF2-40B4-BE49-F238E27FC236}">
-                <a16:creationId xmlns:a16="http://schemas.microsoft.com/office/drawing/2014/main" id="{F0F9A418-FCFF-48F3-BDB7-B531639B22BD}"/>
+                <a16:creationId xmlns:a16="http://schemas.microsoft.com/office/drawing/2014/main" id="{EACDD762-51B4-4ED7-8BD8-55D494C191F1}"/>
               </a:ext>
             </a:extLst>
           </p:cNvPr>
@@ -2309,7 +2443,7 @@
           <p:cNvPr id="4" name="">
             <a:extLst xmlns:a="http://schemas.openxmlformats.org/drawingml/2006/main">
               <a:ext uri="{FF2B5EF4-FFF2-40B4-BE49-F238E27FC236}">
-                <a16:creationId xmlns:a16="http://schemas.microsoft.com/office/drawing/2014/main" id="{788CA22D-FA74-458D-AD76-46888626257A}"/>
+                <a16:creationId xmlns:a16="http://schemas.microsoft.com/office/drawing/2014/main" id="{C4390CF3-8863-4520-94A8-6EB0EC370956}"/>
               </a:ext>
             </a:extLst>
           </p:cNvPr>
@@ -2366,7 +2500,7 @@
           <p:cNvPr id="5" name="">
             <a:extLst xmlns:a="http://schemas.openxmlformats.org/drawingml/2006/main">
               <a:ext uri="{FF2B5EF4-FFF2-40B4-BE49-F238E27FC236}">
-                <a16:creationId xmlns:a16="http://schemas.microsoft.com/office/drawing/2014/main" id="{9F673813-851E-4A42-A2A9-C50C3BEE2101}"/>
+                <a16:creationId xmlns:a16="http://schemas.microsoft.com/office/drawing/2014/main" id="{323DE5D8-B1E1-4127-8F5B-EBF4E63FF158}"/>
               </a:ext>
             </a:extLst>
           </p:cNvPr>
@@ -2423,7 +2557,7 @@
           <p:cNvPr id="6" name="">
             <a:extLst xmlns:a="http://schemas.openxmlformats.org/drawingml/2006/main">
               <a:ext uri="{FF2B5EF4-FFF2-40B4-BE49-F238E27FC236}">
-                <a16:creationId xmlns:a16="http://schemas.microsoft.com/office/drawing/2014/main" id="{4D81B4AD-7C88-4B9D-9A57-A29016DFCEE7}"/>
+                <a16:creationId xmlns:a16="http://schemas.microsoft.com/office/drawing/2014/main" id="{CF33B959-2974-45B4-B9FF-A6A1A7C98373}"/>
               </a:ext>
             </a:extLst>
           </p:cNvPr>
@@ -2480,7 +2614,7 @@
           <p:cNvPr id="7" name="">
             <a:extLst xmlns:a="http://schemas.openxmlformats.org/drawingml/2006/main">
               <a:ext uri="{FF2B5EF4-FFF2-40B4-BE49-F238E27FC236}">
-                <a16:creationId xmlns:a16="http://schemas.microsoft.com/office/drawing/2014/main" id="{BDC9F835-EB6B-45D3-89C8-BE5840EA8E74}"/>
+                <a16:creationId xmlns:a16="http://schemas.microsoft.com/office/drawing/2014/main" id="{212BCA16-64D3-43C3-90E5-9C841C248B6C}"/>
               </a:ext>
             </a:extLst>
           </p:cNvPr>
@@ -2567,7 +2701,7 @@
           <p:cNvPr id="8" name="">
             <a:extLst xmlns:a="http://schemas.openxmlformats.org/drawingml/2006/main">
               <a:ext uri="{FF2B5EF4-FFF2-40B4-BE49-F238E27FC236}">
-                <a16:creationId xmlns:a16="http://schemas.microsoft.com/office/drawing/2014/main" id="{06946490-4E03-405D-A99B-DDAC47AD76A6}"/>
+                <a16:creationId xmlns:a16="http://schemas.microsoft.com/office/drawing/2014/main" id="{F5392225-3869-4511-917A-ED3C7E486961}"/>
               </a:ext>
             </a:extLst>
           </p:cNvPr>
@@ -2624,7 +2758,7 @@
           <p:cNvPr id="9" name="">
             <a:extLst xmlns:a="http://schemas.openxmlformats.org/drawingml/2006/main">
               <a:ext uri="{FF2B5EF4-FFF2-40B4-BE49-F238E27FC236}">
-                <a16:creationId xmlns:a16="http://schemas.microsoft.com/office/drawing/2014/main" id="{3CF92B6E-B04C-4738-BB5F-2F65FF2DC3A9}"/>
+                <a16:creationId xmlns:a16="http://schemas.microsoft.com/office/drawing/2014/main" id="{289D822A-D83D-46D5-840F-DF7B8A42D9CD}"/>
               </a:ext>
             </a:extLst>
           </p:cNvPr>
@@ -2711,7 +2845,7 @@
           <p:cNvPr id="10" name="">
             <a:extLst xmlns:a="http://schemas.openxmlformats.org/drawingml/2006/main">
               <a:ext uri="{FF2B5EF4-FFF2-40B4-BE49-F238E27FC236}">
-                <a16:creationId xmlns:a16="http://schemas.microsoft.com/office/drawing/2014/main" id="{20CCC5EF-243D-4874-9882-CD116AA429F3}"/>
+                <a16:creationId xmlns:a16="http://schemas.microsoft.com/office/drawing/2014/main" id="{E893F834-DEDF-4F16-BBF0-BF562761BE9B}"/>
               </a:ext>
             </a:extLst>
           </p:cNvPr>
@@ -2740,142 +2874,485 @@
             <a:prstDash val="solid"/>
           </a:ln>
         </p:spPr>
-        <p:txBody>
-          <a:bodyPr xmlns:a="http://schemas.openxmlformats.org/drawingml/2006/main">
-            <a:normAutofit fontScale="100000"/>
-          </a:bodyPr>
-          <a:lstStyle xmlns:a="http://schemas.openxmlformats.org/drawingml/2006/main"/>
-          <a:p xmlns:a="http://schemas.openxmlformats.org/drawingml/2006/main">
-            <a:pPr>
-              <a:defRPr sz="1800" b="0">
-                <a:solidFill>
-                  <a:srgbClr val="F8FBFF"/>
-                </a:solidFill>
-                <a:latin typeface="Aptos"/>
-                <a:ea typeface="Aptos"/>
-                <a:cs typeface="Aptos"/>
-              </a:defRPr>
-            </a:pPr>
-            <a:r>
-              <a:rPr sz="1800" b="0">
-                <a:solidFill>
-                  <a:srgbClr val="F8FBFF"/>
-                </a:solidFill>
-                <a:latin typeface="Aptos"/>
-                <a:ea typeface="Aptos"/>
-                <a:cs typeface="Aptos"/>
-              </a:rPr>
-              <a:t>1   Alpha requests SKU-1                         $90</a:t>
-            </a:r>
-          </a:p>
-          <a:p xmlns:a="http://schemas.openxmlformats.org/drawingml/2006/main">
-            <a:r>
-              <a:t/>
-            </a:r>
-          </a:p>
-          <a:p xmlns:a="http://schemas.openxmlformats.org/drawingml/2006/main">
-            <a:pPr>
-              <a:defRPr sz="1800" b="0">
-                <a:solidFill>
-                  <a:srgbClr val="F8FBFF"/>
-                </a:solidFill>
-                <a:latin typeface="Aptos"/>
-                <a:ea typeface="Aptos"/>
-                <a:cs typeface="Aptos"/>
-              </a:defRPr>
-            </a:pPr>
-            <a:r>
-              <a:rPr sz="1800" b="0">
-                <a:solidFill>
-                  <a:srgbClr val="F8FBFF"/>
-                </a:solidFill>
-                <a:latin typeface="Aptos"/>
-                <a:ea typeface="Aptos"/>
-                <a:cs typeface="Aptos"/>
-              </a:rPr>
-              <a:t>2   Cache stores SKU-1                              $90</a:t>
-            </a:r>
-          </a:p>
-          <a:p xmlns:a="http://schemas.openxmlformats.org/drawingml/2006/main">
-            <a:r>
-              <a:t/>
-            </a:r>
-          </a:p>
-          <a:p xmlns:a="http://schemas.openxmlformats.org/drawingml/2006/main">
-            <a:pPr>
-              <a:defRPr sz="1800" b="0">
-                <a:solidFill>
-                  <a:srgbClr val="F8FBFF"/>
-                </a:solidFill>
-                <a:latin typeface="Aptos"/>
-                <a:ea typeface="Aptos"/>
-                <a:cs typeface="Aptos"/>
-              </a:defRPr>
-            </a:pPr>
-            <a:r>
-              <a:rPr sz="1800" b="0">
-                <a:solidFill>
-                  <a:srgbClr val="F8FBFF"/>
-                </a:solidFill>
-                <a:latin typeface="Aptos"/>
-                <a:ea typeface="Aptos"/>
-                <a:cs typeface="Aptos"/>
-              </a:rPr>
-              <a:t>3   Beta requests SKU-1                           $90  ✕</a:t>
-            </a:r>
-          </a:p>
-          <a:p xmlns:a="http://schemas.openxmlformats.org/drawingml/2006/main">
-            <a:r>
-              <a:t/>
-            </a:r>
-          </a:p>
-          <a:p xmlns:a="http://schemas.openxmlformats.org/drawingml/2006/main">
-            <a:pPr>
-              <a:defRPr sz="1800" b="0">
-                <a:solidFill>
-                  <a:srgbClr val="F8FBFF"/>
-                </a:solidFill>
-                <a:latin typeface="Aptos"/>
-                <a:ea typeface="Aptos"/>
-                <a:cs typeface="Aptos"/>
-              </a:defRPr>
-            </a:pPr>
-            <a:r>
-              <a:rPr sz="1800" b="0">
-                <a:solidFill>
-                  <a:srgbClr val="F8FBFF"/>
-                </a:solidFill>
-                <a:latin typeface="Aptos"/>
-                <a:ea typeface="Aptos"/>
-                <a:cs typeface="Aptos"/>
-              </a:rPr>
-              <a:t>Expected for Beta                               $100</a:t>
-            </a:r>
-          </a:p>
-        </p:txBody>
       </p:sp>
       <p:sp>
         <p:nvSpPr>
           <p:cNvPr id="11" name="">
             <a:extLst xmlns:a="http://schemas.openxmlformats.org/drawingml/2006/main">
               <a:ext uri="{FF2B5EF4-FFF2-40B4-BE49-F238E27FC236}">
-                <a16:creationId xmlns:a16="http://schemas.microsoft.com/office/drawing/2014/main" id="{1F0BD410-8128-4D8A-8741-7715A10D57CD}"/>
-              </a:ext>
-            </a:extLst>
-          </p:cNvPr>
-          <p:cNvSpPr>
-            <a:spLocks xmlns:a="http://schemas.openxmlformats.org/drawingml/2006/main" noGrp="1"/>
-          </p:cNvSpPr>
-          <p:nvPr/>
-        </p:nvSpPr>
-        <p:spPr>
-          <a:xfrm xmlns:a="http://schemas.openxmlformats.org/drawingml/2006/main">
-            <a:off x="8439150" y="4210050"/>
-            <a:ext cx="1905000" cy="381000"/>
+                <a16:creationId xmlns:a16="http://schemas.microsoft.com/office/drawing/2014/main" id="{B33412C9-0867-48EB-9777-8F88801AE89E}"/>
+              </a:ext>
+            </a:extLst>
+          </p:cNvPr>
+          <p:cNvSpPr>
+            <a:spLocks xmlns:a="http://schemas.openxmlformats.org/drawingml/2006/main" noGrp="1"/>
+          </p:cNvSpPr>
+          <p:nvPr/>
+        </p:nvSpPr>
+        <p:spPr>
+          <a:xfrm xmlns:a="http://schemas.openxmlformats.org/drawingml/2006/main">
+            <a:off x="4572000" y="2686050"/>
+            <a:ext cx="4343400" cy="342900"/>
+          </a:xfrm>
+          <a:prstGeom xmlns:a="http://schemas.openxmlformats.org/drawingml/2006/main" prst="rect">
+            <a:avLst/>
+          </a:prstGeom>
+          <a:noFill xmlns:a="http://schemas.openxmlformats.org/drawingml/2006/main"/>
+          <a:ln xmlns:a="http://schemas.openxmlformats.org/drawingml/2006/main" w="0">
+            <a:noFill/>
+          </a:ln>
+        </p:spPr>
+        <p:txBody>
+          <a:bodyPr xmlns:a="http://schemas.openxmlformats.org/drawingml/2006/main">
+            <a:normAutofit fontScale="95652"/>
+          </a:bodyPr>
+          <a:lstStyle xmlns:a="http://schemas.openxmlformats.org/drawingml/2006/main"/>
+          <a:p xmlns:a="http://schemas.openxmlformats.org/drawingml/2006/main">
+            <a:pPr>
+              <a:defRPr sz="1725" b="0">
+                <a:solidFill>
+                  <a:srgbClr val="F8FBFF"/>
+                </a:solidFill>
+                <a:latin typeface="Aptos"/>
+                <a:ea typeface="Aptos"/>
+                <a:cs typeface="Aptos"/>
+              </a:defRPr>
+            </a:pPr>
+            <a:r>
+              <a:rPr sz="1725" b="0">
+                <a:solidFill>
+                  <a:srgbClr val="F8FBFF"/>
+                </a:solidFill>
+                <a:latin typeface="Aptos"/>
+                <a:ea typeface="Aptos"/>
+                <a:cs typeface="Aptos"/>
+              </a:rPr>
+              <a:t>1   Alpha requests SKU-1</a:t>
+            </a:r>
+          </a:p>
+        </p:txBody>
+      </p:sp>
+      <p:sp>
+        <p:nvSpPr>
+          <p:cNvPr id="12" name="">
+            <a:extLst xmlns:a="http://schemas.openxmlformats.org/drawingml/2006/main">
+              <a:ext uri="{FF2B5EF4-FFF2-40B4-BE49-F238E27FC236}">
+                <a16:creationId xmlns:a16="http://schemas.microsoft.com/office/drawing/2014/main" id="{D21A1086-A3D8-4479-9B43-A133F1AEE9D7}"/>
+              </a:ext>
+            </a:extLst>
+          </p:cNvPr>
+          <p:cNvSpPr>
+            <a:spLocks xmlns:a="http://schemas.openxmlformats.org/drawingml/2006/main" noGrp="1"/>
+          </p:cNvSpPr>
+          <p:nvPr/>
+        </p:nvSpPr>
+        <p:spPr>
+          <a:xfrm xmlns:a="http://schemas.openxmlformats.org/drawingml/2006/main">
+            <a:off x="9124950" y="2686050"/>
+            <a:ext cx="1447800" cy="342900"/>
+          </a:xfrm>
+          <a:prstGeom xmlns:a="http://schemas.openxmlformats.org/drawingml/2006/main" prst="rect">
+            <a:avLst/>
+          </a:prstGeom>
+          <a:noFill xmlns:a="http://schemas.openxmlformats.org/drawingml/2006/main"/>
+          <a:ln xmlns:a="http://schemas.openxmlformats.org/drawingml/2006/main" w="0">
+            <a:noFill/>
+          </a:ln>
+        </p:spPr>
+        <p:txBody>
+          <a:bodyPr xmlns:a="http://schemas.openxmlformats.org/drawingml/2006/main">
+            <a:normAutofit fontScale="95652"/>
+          </a:bodyPr>
+          <a:lstStyle xmlns:a="http://schemas.openxmlformats.org/drawingml/2006/main"/>
+          <a:p xmlns:a="http://schemas.openxmlformats.org/drawingml/2006/main">
+            <a:pPr>
+              <a:defRPr sz="1725" b="0">
+                <a:solidFill>
+                  <a:srgbClr val="F8FBFF"/>
+                </a:solidFill>
+                <a:latin typeface="Aptos"/>
+                <a:ea typeface="Aptos"/>
+                <a:cs typeface="Aptos"/>
+              </a:defRPr>
+            </a:pPr>
+            <a:r>
+              <a:rPr sz="1725" b="0">
+                <a:solidFill>
+                  <a:srgbClr val="F8FBFF"/>
+                </a:solidFill>
+                <a:latin typeface="Aptos"/>
+                <a:ea typeface="Aptos"/>
+                <a:cs typeface="Aptos"/>
+              </a:rPr>
+              <a:t>$90</a:t>
+            </a:r>
+          </a:p>
+        </p:txBody>
+      </p:sp>
+      <p:sp>
+        <p:nvSpPr>
+          <p:cNvPr id="13" name="">
+            <a:extLst xmlns:a="http://schemas.openxmlformats.org/drawingml/2006/main">
+              <a:ext uri="{FF2B5EF4-FFF2-40B4-BE49-F238E27FC236}">
+                <a16:creationId xmlns:a16="http://schemas.microsoft.com/office/drawing/2014/main" id="{7DCC1111-ED86-40DE-9F1C-61BC0456CC77}"/>
+              </a:ext>
+            </a:extLst>
+          </p:cNvPr>
+          <p:cNvSpPr>
+            <a:spLocks xmlns:a="http://schemas.openxmlformats.org/drawingml/2006/main" noGrp="1"/>
+          </p:cNvSpPr>
+          <p:nvPr/>
+        </p:nvSpPr>
+        <p:spPr>
+          <a:xfrm xmlns:a="http://schemas.openxmlformats.org/drawingml/2006/main">
+            <a:off x="4572000" y="3238500"/>
+            <a:ext cx="4343400" cy="342900"/>
+          </a:xfrm>
+          <a:prstGeom xmlns:a="http://schemas.openxmlformats.org/drawingml/2006/main" prst="rect">
+            <a:avLst/>
+          </a:prstGeom>
+          <a:noFill xmlns:a="http://schemas.openxmlformats.org/drawingml/2006/main"/>
+          <a:ln xmlns:a="http://schemas.openxmlformats.org/drawingml/2006/main" w="0">
+            <a:noFill/>
+          </a:ln>
+        </p:spPr>
+        <p:txBody>
+          <a:bodyPr xmlns:a="http://schemas.openxmlformats.org/drawingml/2006/main">
+            <a:normAutofit fontScale="95652"/>
+          </a:bodyPr>
+          <a:lstStyle xmlns:a="http://schemas.openxmlformats.org/drawingml/2006/main"/>
+          <a:p xmlns:a="http://schemas.openxmlformats.org/drawingml/2006/main">
+            <a:pPr>
+              <a:defRPr sz="1725" b="0">
+                <a:solidFill>
+                  <a:srgbClr val="F8FBFF"/>
+                </a:solidFill>
+                <a:latin typeface="Aptos"/>
+                <a:ea typeface="Aptos"/>
+                <a:cs typeface="Aptos"/>
+              </a:defRPr>
+            </a:pPr>
+            <a:r>
+              <a:rPr sz="1725" b="0">
+                <a:solidFill>
+                  <a:srgbClr val="F8FBFF"/>
+                </a:solidFill>
+                <a:latin typeface="Aptos"/>
+                <a:ea typeface="Aptos"/>
+                <a:cs typeface="Aptos"/>
+              </a:rPr>
+              <a:t>2   Cache stores SKU-1</a:t>
+            </a:r>
+          </a:p>
+        </p:txBody>
+      </p:sp>
+      <p:sp>
+        <p:nvSpPr>
+          <p:cNvPr id="14" name="">
+            <a:extLst xmlns:a="http://schemas.openxmlformats.org/drawingml/2006/main">
+              <a:ext uri="{FF2B5EF4-FFF2-40B4-BE49-F238E27FC236}">
+                <a16:creationId xmlns:a16="http://schemas.microsoft.com/office/drawing/2014/main" id="{E667DC07-BAF5-48D0-92E9-344EAF5F9ACA}"/>
+              </a:ext>
+            </a:extLst>
+          </p:cNvPr>
+          <p:cNvSpPr>
+            <a:spLocks xmlns:a="http://schemas.openxmlformats.org/drawingml/2006/main" noGrp="1"/>
+          </p:cNvSpPr>
+          <p:nvPr/>
+        </p:nvSpPr>
+        <p:spPr>
+          <a:xfrm xmlns:a="http://schemas.openxmlformats.org/drawingml/2006/main">
+            <a:off x="9124950" y="3238500"/>
+            <a:ext cx="1447800" cy="342900"/>
+          </a:xfrm>
+          <a:prstGeom xmlns:a="http://schemas.openxmlformats.org/drawingml/2006/main" prst="rect">
+            <a:avLst/>
+          </a:prstGeom>
+          <a:noFill xmlns:a="http://schemas.openxmlformats.org/drawingml/2006/main"/>
+          <a:ln xmlns:a="http://schemas.openxmlformats.org/drawingml/2006/main" w="0">
+            <a:noFill/>
+          </a:ln>
+        </p:spPr>
+        <p:txBody>
+          <a:bodyPr xmlns:a="http://schemas.openxmlformats.org/drawingml/2006/main">
+            <a:normAutofit fontScale="95652"/>
+          </a:bodyPr>
+          <a:lstStyle xmlns:a="http://schemas.openxmlformats.org/drawingml/2006/main"/>
+          <a:p xmlns:a="http://schemas.openxmlformats.org/drawingml/2006/main">
+            <a:pPr>
+              <a:defRPr sz="1725" b="0">
+                <a:solidFill>
+                  <a:srgbClr val="F8FBFF"/>
+                </a:solidFill>
+                <a:latin typeface="Aptos"/>
+                <a:ea typeface="Aptos"/>
+                <a:cs typeface="Aptos"/>
+              </a:defRPr>
+            </a:pPr>
+            <a:r>
+              <a:rPr sz="1725" b="0">
+                <a:solidFill>
+                  <a:srgbClr val="F8FBFF"/>
+                </a:solidFill>
+                <a:latin typeface="Aptos"/>
+                <a:ea typeface="Aptos"/>
+                <a:cs typeface="Aptos"/>
+              </a:rPr>
+              <a:t>$90</a:t>
+            </a:r>
+          </a:p>
+        </p:txBody>
+      </p:sp>
+      <p:sp>
+        <p:nvSpPr>
+          <p:cNvPr id="15" name="">
+            <a:extLst xmlns:a="http://schemas.openxmlformats.org/drawingml/2006/main">
+              <a:ext uri="{FF2B5EF4-FFF2-40B4-BE49-F238E27FC236}">
+                <a16:creationId xmlns:a16="http://schemas.microsoft.com/office/drawing/2014/main" id="{7A9430EE-7347-4C02-A469-BB30D912FFF3}"/>
+              </a:ext>
+            </a:extLst>
+          </p:cNvPr>
+          <p:cNvSpPr>
+            <a:spLocks xmlns:a="http://schemas.openxmlformats.org/drawingml/2006/main" noGrp="1"/>
+          </p:cNvSpPr>
+          <p:nvPr/>
+        </p:nvSpPr>
+        <p:spPr>
+          <a:xfrm xmlns:a="http://schemas.openxmlformats.org/drawingml/2006/main">
+            <a:off x="4572000" y="3790950"/>
+            <a:ext cx="4343400" cy="342900"/>
+          </a:xfrm>
+          <a:prstGeom xmlns:a="http://schemas.openxmlformats.org/drawingml/2006/main" prst="rect">
+            <a:avLst/>
+          </a:prstGeom>
+          <a:noFill xmlns:a="http://schemas.openxmlformats.org/drawingml/2006/main"/>
+          <a:ln xmlns:a="http://schemas.openxmlformats.org/drawingml/2006/main" w="0">
+            <a:noFill/>
+          </a:ln>
+        </p:spPr>
+        <p:txBody>
+          <a:bodyPr xmlns:a="http://schemas.openxmlformats.org/drawingml/2006/main">
+            <a:normAutofit fontScale="95652"/>
+          </a:bodyPr>
+          <a:lstStyle xmlns:a="http://schemas.openxmlformats.org/drawingml/2006/main"/>
+          <a:p xmlns:a="http://schemas.openxmlformats.org/drawingml/2006/main">
+            <a:pPr>
+              <a:defRPr sz="1725" b="0">
+                <a:solidFill>
+                  <a:srgbClr val="F8FBFF"/>
+                </a:solidFill>
+                <a:latin typeface="Aptos"/>
+                <a:ea typeface="Aptos"/>
+                <a:cs typeface="Aptos"/>
+              </a:defRPr>
+            </a:pPr>
+            <a:r>
+              <a:rPr sz="1725" b="0">
+                <a:solidFill>
+                  <a:srgbClr val="F8FBFF"/>
+                </a:solidFill>
+                <a:latin typeface="Aptos"/>
+                <a:ea typeface="Aptos"/>
+                <a:cs typeface="Aptos"/>
+              </a:rPr>
+              <a:t>3   Beta requests SKU-1</a:t>
+            </a:r>
+          </a:p>
+        </p:txBody>
+      </p:sp>
+      <p:sp>
+        <p:nvSpPr>
+          <p:cNvPr id="16" name="">
+            <a:extLst xmlns:a="http://schemas.openxmlformats.org/drawingml/2006/main">
+              <a:ext uri="{FF2B5EF4-FFF2-40B4-BE49-F238E27FC236}">
+                <a16:creationId xmlns:a16="http://schemas.microsoft.com/office/drawing/2014/main" id="{BCD140E6-A406-4BEE-9D02-2DAD31EE91B2}"/>
+              </a:ext>
+            </a:extLst>
+          </p:cNvPr>
+          <p:cNvSpPr>
+            <a:spLocks xmlns:a="http://schemas.openxmlformats.org/drawingml/2006/main" noGrp="1"/>
+          </p:cNvSpPr>
+          <p:nvPr/>
+        </p:nvSpPr>
+        <p:spPr>
+          <a:xfrm xmlns:a="http://schemas.openxmlformats.org/drawingml/2006/main">
+            <a:off x="9124950" y="3790950"/>
+            <a:ext cx="1447800" cy="342900"/>
+          </a:xfrm>
+          <a:prstGeom xmlns:a="http://schemas.openxmlformats.org/drawingml/2006/main" prst="rect">
+            <a:avLst/>
+          </a:prstGeom>
+          <a:noFill xmlns:a="http://schemas.openxmlformats.org/drawingml/2006/main"/>
+          <a:ln xmlns:a="http://schemas.openxmlformats.org/drawingml/2006/main" w="0">
+            <a:noFill/>
+          </a:ln>
+        </p:spPr>
+        <p:txBody>
+          <a:bodyPr xmlns:a="http://schemas.openxmlformats.org/drawingml/2006/main">
+            <a:normAutofit fontScale="95652"/>
+          </a:bodyPr>
+          <a:lstStyle xmlns:a="http://schemas.openxmlformats.org/drawingml/2006/main"/>
+          <a:p xmlns:a="http://schemas.openxmlformats.org/drawingml/2006/main">
+            <a:pPr>
+              <a:defRPr sz="1725" b="1">
+                <a:solidFill>
+                  <a:srgbClr val="FF6B7A"/>
+                </a:solidFill>
+                <a:latin typeface="Aptos"/>
+                <a:ea typeface="Aptos"/>
+                <a:cs typeface="Aptos"/>
+              </a:defRPr>
+            </a:pPr>
+            <a:r>
+              <a:rPr sz="1725" b="1">
+                <a:solidFill>
+                  <a:srgbClr val="FF6B7A"/>
+                </a:solidFill>
+                <a:latin typeface="Aptos"/>
+                <a:ea typeface="Aptos"/>
+                <a:cs typeface="Aptos"/>
+              </a:rPr>
+              <a:t>$90  ✕</a:t>
+            </a:r>
+          </a:p>
+        </p:txBody>
+      </p:sp>
+      <p:sp>
+        <p:nvSpPr>
+          <p:cNvPr id="17" name="">
+            <a:extLst xmlns:a="http://schemas.openxmlformats.org/drawingml/2006/main">
+              <a:ext uri="{FF2B5EF4-FFF2-40B4-BE49-F238E27FC236}">
+                <a16:creationId xmlns:a16="http://schemas.microsoft.com/office/drawing/2014/main" id="{575B1098-0F2E-427D-AC0E-F0639B9A34DB}"/>
+              </a:ext>
+            </a:extLst>
+          </p:cNvPr>
+          <p:cNvSpPr>
+            <a:spLocks xmlns:a="http://schemas.openxmlformats.org/drawingml/2006/main" noGrp="1"/>
+          </p:cNvSpPr>
+          <p:nvPr/>
+        </p:nvSpPr>
+        <p:spPr>
+          <a:xfrm xmlns:a="http://schemas.openxmlformats.org/drawingml/2006/main">
+            <a:off x="4572000" y="4438650"/>
+            <a:ext cx="4343400" cy="342900"/>
+          </a:xfrm>
+          <a:prstGeom xmlns:a="http://schemas.openxmlformats.org/drawingml/2006/main" prst="rect">
+            <a:avLst/>
+          </a:prstGeom>
+          <a:noFill xmlns:a="http://schemas.openxmlformats.org/drawingml/2006/main"/>
+          <a:ln xmlns:a="http://schemas.openxmlformats.org/drawingml/2006/main" w="0">
+            <a:noFill/>
+          </a:ln>
+        </p:spPr>
+        <p:txBody>
+          <a:bodyPr xmlns:a="http://schemas.openxmlformats.org/drawingml/2006/main">
+            <a:normAutofit fontScale="95652"/>
+          </a:bodyPr>
+          <a:lstStyle xmlns:a="http://schemas.openxmlformats.org/drawingml/2006/main"/>
+          <a:p xmlns:a="http://schemas.openxmlformats.org/drawingml/2006/main">
+            <a:pPr>
+              <a:defRPr sz="1725" b="0">
+                <a:solidFill>
+                  <a:srgbClr val="F8FBFF"/>
+                </a:solidFill>
+                <a:latin typeface="Aptos"/>
+                <a:ea typeface="Aptos"/>
+                <a:cs typeface="Aptos"/>
+              </a:defRPr>
+            </a:pPr>
+            <a:r>
+              <a:rPr sz="1725" b="0">
+                <a:solidFill>
+                  <a:srgbClr val="F8FBFF"/>
+                </a:solidFill>
+                <a:latin typeface="Aptos"/>
+                <a:ea typeface="Aptos"/>
+                <a:cs typeface="Aptos"/>
+              </a:rPr>
+              <a:t>Expected for Beta</a:t>
+            </a:r>
+          </a:p>
+        </p:txBody>
+      </p:sp>
+      <p:sp>
+        <p:nvSpPr>
+          <p:cNvPr id="18" name="">
+            <a:extLst xmlns:a="http://schemas.openxmlformats.org/drawingml/2006/main">
+              <a:ext uri="{FF2B5EF4-FFF2-40B4-BE49-F238E27FC236}">
+                <a16:creationId xmlns:a16="http://schemas.microsoft.com/office/drawing/2014/main" id="{6F66BE45-8132-4886-917E-2A2ADBE5803A}"/>
+              </a:ext>
+            </a:extLst>
+          </p:cNvPr>
+          <p:cNvSpPr>
+            <a:spLocks xmlns:a="http://schemas.openxmlformats.org/drawingml/2006/main" noGrp="1"/>
+          </p:cNvSpPr>
+          <p:nvPr/>
+        </p:nvSpPr>
+        <p:spPr>
+          <a:xfrm xmlns:a="http://schemas.openxmlformats.org/drawingml/2006/main">
+            <a:off x="9124950" y="4438650"/>
+            <a:ext cx="1447800" cy="342900"/>
+          </a:xfrm>
+          <a:prstGeom xmlns:a="http://schemas.openxmlformats.org/drawingml/2006/main" prst="rect">
+            <a:avLst/>
+          </a:prstGeom>
+          <a:noFill xmlns:a="http://schemas.openxmlformats.org/drawingml/2006/main"/>
+          <a:ln xmlns:a="http://schemas.openxmlformats.org/drawingml/2006/main" w="0">
+            <a:noFill/>
+          </a:ln>
+        </p:spPr>
+        <p:txBody>
+          <a:bodyPr xmlns:a="http://schemas.openxmlformats.org/drawingml/2006/main">
+            <a:normAutofit fontScale="95652"/>
+          </a:bodyPr>
+          <a:lstStyle xmlns:a="http://schemas.openxmlformats.org/drawingml/2006/main"/>
+          <a:p xmlns:a="http://schemas.openxmlformats.org/drawingml/2006/main">
+            <a:pPr>
+              <a:defRPr sz="1725" b="1">
+                <a:solidFill>
+                  <a:srgbClr val="B8F56A"/>
+                </a:solidFill>
+                <a:latin typeface="Aptos"/>
+                <a:ea typeface="Aptos"/>
+                <a:cs typeface="Aptos"/>
+              </a:defRPr>
+            </a:pPr>
+            <a:r>
+              <a:rPr sz="1725" b="1">
+                <a:solidFill>
+                  <a:srgbClr val="B8F56A"/>
+                </a:solidFill>
+                <a:latin typeface="Aptos"/>
+                <a:ea typeface="Aptos"/>
+                <a:cs typeface="Aptos"/>
+              </a:rPr>
+              <a:t>$100</a:t>
+            </a:r>
+          </a:p>
+        </p:txBody>
+      </p:sp>
+      <p:sp>
+        <p:nvSpPr>
+          <p:cNvPr id="19" name="">
+            <a:extLst xmlns:a="http://schemas.openxmlformats.org/drawingml/2006/main">
+              <a:ext uri="{FF2B5EF4-FFF2-40B4-BE49-F238E27FC236}">
+                <a16:creationId xmlns:a16="http://schemas.microsoft.com/office/drawing/2014/main" id="{46EC3E1C-99A2-47AB-87CD-E735A39DCA03}"/>
+              </a:ext>
+            </a:extLst>
+          </p:cNvPr>
+          <p:cNvSpPr>
+            <a:spLocks xmlns:a="http://schemas.openxmlformats.org/drawingml/2006/main" noGrp="1"/>
+          </p:cNvSpPr>
+          <p:nvPr/>
+        </p:nvSpPr>
+        <p:spPr>
+          <a:xfrm xmlns:a="http://schemas.openxmlformats.org/drawingml/2006/main">
+            <a:off x="7810500" y="5105400"/>
+            <a:ext cx="3009900" cy="342900"/>
           </a:xfrm>
           <a:prstGeom xmlns:a="http://schemas.openxmlformats.org/drawingml/2006/main" prst="roundRect">
             <a:avLst>
-              <a:gd name="adj" fmla="val 25000"/>
+              <a:gd name="adj" fmla="val 27778"/>
             </a:avLst>
           </a:prstGeom>
           <a:solidFill xmlns:a="http://schemas.openxmlformats.org/drawingml/2006/main">
@@ -2913,17 +3390,17 @@
                 <a:ea typeface="Aptos"/>
                 <a:cs typeface="Aptos"/>
               </a:rPr>
-              <a:t>price[SKU-1] = 90</a:t>
-            </a:r>
-          </a:p>
-        </p:txBody>
-      </p:sp>
-      <p:sp>
-        <p:nvSpPr>
-          <p:cNvPr id="12" name="">
-            <a:extLst xmlns:a="http://schemas.openxmlformats.org/drawingml/2006/main">
-              <a:ext uri="{FF2B5EF4-FFF2-40B4-BE49-F238E27FC236}">
-                <a16:creationId xmlns:a16="http://schemas.microsoft.com/office/drawing/2014/main" id="{DBA7E3C5-B620-46F4-968F-36FC2AF3AC7D}"/>
+              <a:t>Cache key omits the tenant</a:t>
+            </a:r>
+          </a:p>
+        </p:txBody>
+      </p:sp>
+      <p:sp>
+        <p:nvSpPr>
+          <p:cNvPr id="20" name="">
+            <a:extLst xmlns:a="http://schemas.openxmlformats.org/drawingml/2006/main">
+              <a:ext uri="{FF2B5EF4-FFF2-40B4-BE49-F238E27FC236}">
+                <a16:creationId xmlns:a16="http://schemas.microsoft.com/office/drawing/2014/main" id="{A4347DA3-1FB2-45E1-ADBA-A38373EAE4A3}"/>
               </a:ext>
             </a:extLst>
           </p:cNvPr>
@@ -2978,7 +3455,7 @@
     </p:spTree>
     <p:extLst>
       <p:ext uri="{BB962C8B-B14F-4D97-AF65-F5344CB8AC3E}">
-        <p14:creationId xmlns:p14="http://schemas.microsoft.com/office/powerpoint/2010/main" val="1426317420"/>
+        <p14:creationId xmlns:p14="http://schemas.microsoft.com/office/powerpoint/2010/main" val="145512655"/>
       </p:ext>
     </p:extLst>
   </p:cSld>
@@ -3009,7 +3486,7 @@
           <p:cNvPr id="28" name="">
             <a:extLst xmlns:a="http://schemas.openxmlformats.org/drawingml/2006/main">
               <a:ext uri="{FF2B5EF4-FFF2-40B4-BE49-F238E27FC236}">
-                <a16:creationId xmlns:a16="http://schemas.microsoft.com/office/drawing/2014/main" id="{CF6D79DD-B395-40C6-B13A-CE6D54AC3BE9}"/>
+                <a16:creationId xmlns:a16="http://schemas.microsoft.com/office/drawing/2014/main" id="{3CF72B84-7206-4497-8DC7-45429618D7DA}"/>
               </a:ext>
             </a:extLst>
           </p:cNvPr>
@@ -3039,7 +3516,7 @@
           <p:cNvPr id="2" name="">
             <a:extLst xmlns:a="http://schemas.openxmlformats.org/drawingml/2006/main">
               <a:ext uri="{FF2B5EF4-FFF2-40B4-BE49-F238E27FC236}">
-                <a16:creationId xmlns:a16="http://schemas.microsoft.com/office/drawing/2014/main" id="{02CE7B14-EB08-44E0-9DCD-ED620ACC7A8F}"/>
+                <a16:creationId xmlns:a16="http://schemas.microsoft.com/office/drawing/2014/main" id="{49B7155D-7C5D-49D8-B6AC-3652F27C53F1}"/>
               </a:ext>
             </a:extLst>
           </p:cNvPr>
@@ -3096,7 +3573,7 @@
           <p:cNvPr id="3" name="">
             <a:extLst xmlns:a="http://schemas.openxmlformats.org/drawingml/2006/main">
               <a:ext uri="{FF2B5EF4-FFF2-40B4-BE49-F238E27FC236}">
-                <a16:creationId xmlns:a16="http://schemas.microsoft.com/office/drawing/2014/main" id="{B424F95B-9ABB-489E-AD11-AD0B335F4FA6}"/>
+                <a16:creationId xmlns:a16="http://schemas.microsoft.com/office/drawing/2014/main" id="{39FEB35F-71CD-419A-A2FE-A25B5FC24AE5}"/>
               </a:ext>
             </a:extLst>
           </p:cNvPr>
@@ -3153,7 +3630,7 @@
           <p:cNvPr id="4" name="">
             <a:extLst xmlns:a="http://schemas.openxmlformats.org/drawingml/2006/main">
               <a:ext uri="{FF2B5EF4-FFF2-40B4-BE49-F238E27FC236}">
-                <a16:creationId xmlns:a16="http://schemas.microsoft.com/office/drawing/2014/main" id="{7E7DDF12-9C30-4C4B-98D3-E0683F37F60E}"/>
+                <a16:creationId xmlns:a16="http://schemas.microsoft.com/office/drawing/2014/main" id="{E5EE249B-AD2C-4AE6-8B48-5831E9CFB848}"/>
               </a:ext>
             </a:extLst>
           </p:cNvPr>
@@ -3210,7 +3687,7 @@
           <p:cNvPr id="5" name="">
             <a:extLst xmlns:a="http://schemas.openxmlformats.org/drawingml/2006/main">
               <a:ext uri="{FF2B5EF4-FFF2-40B4-BE49-F238E27FC236}">
-                <a16:creationId xmlns:a16="http://schemas.microsoft.com/office/drawing/2014/main" id="{3097978F-BC5E-4063-8F52-096AECD88F59}"/>
+                <a16:creationId xmlns:a16="http://schemas.microsoft.com/office/drawing/2014/main" id="{9CB92AD7-D9AB-4D2D-AA8E-064EF255FA8E}"/>
               </a:ext>
             </a:extLst>
           </p:cNvPr>
@@ -3267,7 +3744,7 @@
           <p:cNvPr id="6" name="">
             <a:extLst xmlns:a="http://schemas.openxmlformats.org/drawingml/2006/main">
               <a:ext uri="{FF2B5EF4-FFF2-40B4-BE49-F238E27FC236}">
-                <a16:creationId xmlns:a16="http://schemas.microsoft.com/office/drawing/2014/main" id="{B3BBDA1B-4301-49FA-A420-B10552D6DF33}"/>
+                <a16:creationId xmlns:a16="http://schemas.microsoft.com/office/drawing/2014/main" id="{EDEB23C9-5484-49E7-B8CC-7A78B9420DBA}"/>
               </a:ext>
             </a:extLst>
           </p:cNvPr>
@@ -3331,7 +3808,7 @@
           <p:cNvPr id="7" name="">
             <a:extLst xmlns:a="http://schemas.openxmlformats.org/drawingml/2006/main">
               <a:ext uri="{FF2B5EF4-FFF2-40B4-BE49-F238E27FC236}">
-                <a16:creationId xmlns:a16="http://schemas.microsoft.com/office/drawing/2014/main" id="{25DD63C6-9F3B-43BB-8FE5-365C31DC4697}"/>
+                <a16:creationId xmlns:a16="http://schemas.microsoft.com/office/drawing/2014/main" id="{E3199616-3851-4990-B66E-0958B06EECEB}"/>
               </a:ext>
             </a:extLst>
           </p:cNvPr>
@@ -3395,7 +3872,7 @@
           <p:cNvPr id="8" name="">
             <a:extLst xmlns:a="http://schemas.openxmlformats.org/drawingml/2006/main">
               <a:ext uri="{FF2B5EF4-FFF2-40B4-BE49-F238E27FC236}">
-                <a16:creationId xmlns:a16="http://schemas.microsoft.com/office/drawing/2014/main" id="{6D43CC94-15F3-4AE4-96D5-C3F3592E8287}"/>
+                <a16:creationId xmlns:a16="http://schemas.microsoft.com/office/drawing/2014/main" id="{0AD025E0-EFAC-405D-AAC3-44E10AA152AE}"/>
               </a:ext>
             </a:extLst>
           </p:cNvPr>
@@ -3425,7 +3902,7 @@
           <p:cNvPr id="9" name="">
             <a:extLst xmlns:a="http://schemas.openxmlformats.org/drawingml/2006/main">
               <a:ext uri="{FF2B5EF4-FFF2-40B4-BE49-F238E27FC236}">
-                <a16:creationId xmlns:a16="http://schemas.microsoft.com/office/drawing/2014/main" id="{71FD8D16-A447-4D68-88CE-48AA3586C0F0}"/>
+                <a16:creationId xmlns:a16="http://schemas.microsoft.com/office/drawing/2014/main" id="{E64193F4-6BF0-4EE8-8398-818575C9F8D3}"/>
               </a:ext>
             </a:extLst>
           </p:cNvPr>
@@ -3482,7 +3959,7 @@
           <p:cNvPr id="10" name="">
             <a:extLst xmlns:a="http://schemas.openxmlformats.org/drawingml/2006/main">
               <a:ext uri="{FF2B5EF4-FFF2-40B4-BE49-F238E27FC236}">
-                <a16:creationId xmlns:a16="http://schemas.microsoft.com/office/drawing/2014/main" id="{2551B558-AB75-440A-9171-A5D5E80B8609}"/>
+                <a16:creationId xmlns:a16="http://schemas.microsoft.com/office/drawing/2014/main" id="{2857F868-7522-4938-A908-B7580F624504}"/>
               </a:ext>
             </a:extLst>
           </p:cNvPr>
@@ -3512,7 +3989,7 @@
           <p:cNvPr id="11" name="">
             <a:extLst xmlns:a="http://schemas.openxmlformats.org/drawingml/2006/main">
               <a:ext uri="{FF2B5EF4-FFF2-40B4-BE49-F238E27FC236}">
-                <a16:creationId xmlns:a16="http://schemas.microsoft.com/office/drawing/2014/main" id="{96D5228C-69CC-4CE0-A12A-82F587ECA1AA}"/>
+                <a16:creationId xmlns:a16="http://schemas.microsoft.com/office/drawing/2014/main" id="{0414A3D2-1A24-40AB-8BAD-34C5807C802C}"/>
               </a:ext>
             </a:extLst>
           </p:cNvPr>
@@ -3569,7 +4046,7 @@
           <p:cNvPr id="12" name="">
             <a:extLst xmlns:a="http://schemas.openxmlformats.org/drawingml/2006/main">
               <a:ext uri="{FF2B5EF4-FFF2-40B4-BE49-F238E27FC236}">
-                <a16:creationId xmlns:a16="http://schemas.microsoft.com/office/drawing/2014/main" id="{7A809AD1-EDB1-4DC2-9321-B8C8942C1A70}"/>
+                <a16:creationId xmlns:a16="http://schemas.microsoft.com/office/drawing/2014/main" id="{3FB0C9AB-FA9F-4FBA-91EE-E43DBAF4B8C9}"/>
               </a:ext>
             </a:extLst>
           </p:cNvPr>
@@ -3633,7 +4110,7 @@
           <p:cNvPr id="13" name="">
             <a:extLst xmlns:a="http://schemas.openxmlformats.org/drawingml/2006/main">
               <a:ext uri="{FF2B5EF4-FFF2-40B4-BE49-F238E27FC236}">
-                <a16:creationId xmlns:a16="http://schemas.microsoft.com/office/drawing/2014/main" id="{7627ABE8-6475-4469-9814-314174A536E4}"/>
+                <a16:creationId xmlns:a16="http://schemas.microsoft.com/office/drawing/2014/main" id="{BA3BED3D-0FB3-42A1-8FB6-7099BB44CFA9}"/>
               </a:ext>
             </a:extLst>
           </p:cNvPr>
@@ -3663,7 +4140,7 @@
           <p:cNvPr id="14" name="">
             <a:extLst xmlns:a="http://schemas.openxmlformats.org/drawingml/2006/main">
               <a:ext uri="{FF2B5EF4-FFF2-40B4-BE49-F238E27FC236}">
-                <a16:creationId xmlns:a16="http://schemas.microsoft.com/office/drawing/2014/main" id="{3024CA5A-1396-469A-BB1E-1044A93D1A57}"/>
+                <a16:creationId xmlns:a16="http://schemas.microsoft.com/office/drawing/2014/main" id="{686B1CDE-394C-4F4D-89A0-0E692DD1CEE9}"/>
               </a:ext>
             </a:extLst>
           </p:cNvPr>
@@ -3720,7 +4197,7 @@
           <p:cNvPr id="15" name="">
             <a:extLst xmlns:a="http://schemas.openxmlformats.org/drawingml/2006/main">
               <a:ext uri="{FF2B5EF4-FFF2-40B4-BE49-F238E27FC236}">
-                <a16:creationId xmlns:a16="http://schemas.microsoft.com/office/drawing/2014/main" id="{8BF93ECC-BFBD-433B-BCBB-4FF065F4433F}"/>
+                <a16:creationId xmlns:a16="http://schemas.microsoft.com/office/drawing/2014/main" id="{36FCE284-A6C1-484F-88C5-610B1B855F2B}"/>
               </a:ext>
             </a:extLst>
           </p:cNvPr>
@@ -3750,7 +4227,7 @@
           <p:cNvPr id="16" name="">
             <a:extLst xmlns:a="http://schemas.openxmlformats.org/drawingml/2006/main">
               <a:ext uri="{FF2B5EF4-FFF2-40B4-BE49-F238E27FC236}">
-                <a16:creationId xmlns:a16="http://schemas.microsoft.com/office/drawing/2014/main" id="{DFEDDAEE-14E9-4362-AFB9-F6E8B39BB29A}"/>
+                <a16:creationId xmlns:a16="http://schemas.microsoft.com/office/drawing/2014/main" id="{39E69D80-DC52-4038-A686-4CD46B91D2F8}"/>
               </a:ext>
             </a:extLst>
           </p:cNvPr>
@@ -3807,7 +4284,7 @@
           <p:cNvPr id="17" name="">
             <a:extLst xmlns:a="http://schemas.openxmlformats.org/drawingml/2006/main">
               <a:ext uri="{FF2B5EF4-FFF2-40B4-BE49-F238E27FC236}">
-                <a16:creationId xmlns:a16="http://schemas.microsoft.com/office/drawing/2014/main" id="{1B9E09E6-EEA2-4CE0-ADE7-0FF39BE6245E}"/>
+                <a16:creationId xmlns:a16="http://schemas.microsoft.com/office/drawing/2014/main" id="{C9323538-0938-4E87-9CE2-4365C15A0893}"/>
               </a:ext>
             </a:extLst>
           </p:cNvPr>
@@ -3871,7 +4348,7 @@
           <p:cNvPr id="18" name="">
             <a:extLst xmlns:a="http://schemas.openxmlformats.org/drawingml/2006/main">
               <a:ext uri="{FF2B5EF4-FFF2-40B4-BE49-F238E27FC236}">
-                <a16:creationId xmlns:a16="http://schemas.microsoft.com/office/drawing/2014/main" id="{D87A1535-5289-4CEF-AA7F-A412A141F719}"/>
+                <a16:creationId xmlns:a16="http://schemas.microsoft.com/office/drawing/2014/main" id="{43372AA4-4372-4489-BA82-A1B7926A5AFC}"/>
               </a:ext>
             </a:extLst>
           </p:cNvPr>
@@ -3901,7 +4378,7 @@
           <p:cNvPr id="19" name="">
             <a:extLst xmlns:a="http://schemas.openxmlformats.org/drawingml/2006/main">
               <a:ext uri="{FF2B5EF4-FFF2-40B4-BE49-F238E27FC236}">
-                <a16:creationId xmlns:a16="http://schemas.microsoft.com/office/drawing/2014/main" id="{1C963A9C-4C10-4BCB-A379-E9982A24CBD2}"/>
+                <a16:creationId xmlns:a16="http://schemas.microsoft.com/office/drawing/2014/main" id="{F0703172-D8BB-4CF8-B7E9-208D54C17222}"/>
               </a:ext>
             </a:extLst>
           </p:cNvPr>
@@ -3958,7 +4435,7 @@
           <p:cNvPr id="20" name="">
             <a:extLst xmlns:a="http://schemas.openxmlformats.org/drawingml/2006/main">
               <a:ext uri="{FF2B5EF4-FFF2-40B4-BE49-F238E27FC236}">
-                <a16:creationId xmlns:a16="http://schemas.microsoft.com/office/drawing/2014/main" id="{AD01F827-71D8-46B9-BC4F-8ABD0165ADCB}"/>
+                <a16:creationId xmlns:a16="http://schemas.microsoft.com/office/drawing/2014/main" id="{38C2D4EF-432E-4F80-92C8-034A7B808E00}"/>
               </a:ext>
             </a:extLst>
           </p:cNvPr>
@@ -3988,7 +4465,7 @@
           <p:cNvPr id="21" name="">
             <a:extLst xmlns:a="http://schemas.openxmlformats.org/drawingml/2006/main">
               <a:ext uri="{FF2B5EF4-FFF2-40B4-BE49-F238E27FC236}">
-                <a16:creationId xmlns:a16="http://schemas.microsoft.com/office/drawing/2014/main" id="{245BFA1C-0349-476E-9A32-148051DED1EB}"/>
+                <a16:creationId xmlns:a16="http://schemas.microsoft.com/office/drawing/2014/main" id="{DF2443B7-9703-4D60-A57D-6BF796980E40}"/>
               </a:ext>
             </a:extLst>
           </p:cNvPr>
@@ -4045,7 +4522,7 @@
           <p:cNvPr id="22" name="">
             <a:extLst xmlns:a="http://schemas.openxmlformats.org/drawingml/2006/main">
               <a:ext uri="{FF2B5EF4-FFF2-40B4-BE49-F238E27FC236}">
-                <a16:creationId xmlns:a16="http://schemas.microsoft.com/office/drawing/2014/main" id="{05D6CE1C-E705-44C1-B927-DF313559DFF5}"/>
+                <a16:creationId xmlns:a16="http://schemas.microsoft.com/office/drawing/2014/main" id="{E84AEB94-B776-4FF2-8E75-3282598A7A74}"/>
               </a:ext>
             </a:extLst>
           </p:cNvPr>
@@ -4109,7 +4586,7 @@
           <p:cNvPr id="23" name="">
             <a:extLst xmlns:a="http://schemas.openxmlformats.org/drawingml/2006/main">
               <a:ext uri="{FF2B5EF4-FFF2-40B4-BE49-F238E27FC236}">
-                <a16:creationId xmlns:a16="http://schemas.microsoft.com/office/drawing/2014/main" id="{5CBE079D-5C74-40F6-97C0-0E8819CCA5D4}"/>
+                <a16:creationId xmlns:a16="http://schemas.microsoft.com/office/drawing/2014/main" id="{DEE705DF-59D3-4B2F-8FEF-768623DCD05A}"/>
               </a:ext>
             </a:extLst>
           </p:cNvPr>
@@ -4139,7 +4616,7 @@
           <p:cNvPr id="24" name="">
             <a:extLst xmlns:a="http://schemas.openxmlformats.org/drawingml/2006/main">
               <a:ext uri="{FF2B5EF4-FFF2-40B4-BE49-F238E27FC236}">
-                <a16:creationId xmlns:a16="http://schemas.microsoft.com/office/drawing/2014/main" id="{5F65DD1C-DBF2-4C1C-B1DB-EBF874D84371}"/>
+                <a16:creationId xmlns:a16="http://schemas.microsoft.com/office/drawing/2014/main" id="{543BDBB6-1F44-432E-B7A0-6F7F1DC54E58}"/>
               </a:ext>
             </a:extLst>
           </p:cNvPr>
@@ -4196,7 +4673,7 @@
           <p:cNvPr id="25" name="">
             <a:extLst xmlns:a="http://schemas.openxmlformats.org/drawingml/2006/main">
               <a:ext uri="{FF2B5EF4-FFF2-40B4-BE49-F238E27FC236}">
-                <a16:creationId xmlns:a16="http://schemas.microsoft.com/office/drawing/2014/main" id="{55461123-479D-4946-ACA9-FFC2EFF2CEDF}"/>
+                <a16:creationId xmlns:a16="http://schemas.microsoft.com/office/drawing/2014/main" id="{6D1D827E-42DB-4230-B8A2-F03D5A779DDC}"/>
               </a:ext>
             </a:extLst>
           </p:cNvPr>
@@ -4226,7 +4703,7 @@
           <p:cNvPr id="26" name="">
             <a:extLst xmlns:a="http://schemas.openxmlformats.org/drawingml/2006/main">
               <a:ext uri="{FF2B5EF4-FFF2-40B4-BE49-F238E27FC236}">
-                <a16:creationId xmlns:a16="http://schemas.microsoft.com/office/drawing/2014/main" id="{676D5563-3573-4034-AD49-002CD8046F78}"/>
+                <a16:creationId xmlns:a16="http://schemas.microsoft.com/office/drawing/2014/main" id="{74E30407-538D-426C-94E4-F10F643B0DAE}"/>
               </a:ext>
             </a:extLst>
           </p:cNvPr>
@@ -4283,7 +4760,7 @@
           <p:cNvPr id="27" name="">
             <a:extLst xmlns:a="http://schemas.openxmlformats.org/drawingml/2006/main">
               <a:ext uri="{FF2B5EF4-FFF2-40B4-BE49-F238E27FC236}">
-                <a16:creationId xmlns:a16="http://schemas.microsoft.com/office/drawing/2014/main" id="{FAF55382-3C75-495A-8D87-2DEF93246A14}"/>
+                <a16:creationId xmlns:a16="http://schemas.microsoft.com/office/drawing/2014/main" id="{3561991A-CCEA-483C-AC51-B5B4A7E0E378}"/>
               </a:ext>
             </a:extLst>
           </p:cNvPr>
@@ -4338,7 +4815,7 @@
     </p:spTree>
     <p:extLst>
       <p:ext uri="{BB962C8B-B14F-4D97-AF65-F5344CB8AC3E}">
-        <p14:creationId xmlns:p14="http://schemas.microsoft.com/office/powerpoint/2010/main" val="459208124"/>
+        <p14:creationId xmlns:p14="http://schemas.microsoft.com/office/powerpoint/2010/main" val="398272716"/>
       </p:ext>
     </p:extLst>
   </p:cSld>
@@ -4369,7 +4846,7 @@
           <p:cNvPr id="22" name="">
             <a:extLst xmlns:a="http://schemas.openxmlformats.org/drawingml/2006/main">
               <a:ext uri="{FF2B5EF4-FFF2-40B4-BE49-F238E27FC236}">
-                <a16:creationId xmlns:a16="http://schemas.microsoft.com/office/drawing/2014/main" id="{F298225A-9603-44B7-B13E-424F24420907}"/>
+                <a16:creationId xmlns:a16="http://schemas.microsoft.com/office/drawing/2014/main" id="{6DD1CD9E-7BBC-40FC-B70F-E5BB32E09B4B}"/>
               </a:ext>
             </a:extLst>
           </p:cNvPr>
@@ -4399,7 +4876,7 @@
           <p:cNvPr id="2" name="">
             <a:extLst xmlns:a="http://schemas.openxmlformats.org/drawingml/2006/main">
               <a:ext uri="{FF2B5EF4-FFF2-40B4-BE49-F238E27FC236}">
-                <a16:creationId xmlns:a16="http://schemas.microsoft.com/office/drawing/2014/main" id="{51A8E2AC-EB86-404A-BFAB-23F85E6189DD}"/>
+                <a16:creationId xmlns:a16="http://schemas.microsoft.com/office/drawing/2014/main" id="{33ABA25C-16C5-4B84-A5F0-2F84551C76CB}"/>
               </a:ext>
             </a:extLst>
           </p:cNvPr>
@@ -4456,7 +4933,7 @@
           <p:cNvPr id="3" name="">
             <a:extLst xmlns:a="http://schemas.openxmlformats.org/drawingml/2006/main">
               <a:ext uri="{FF2B5EF4-FFF2-40B4-BE49-F238E27FC236}">
-                <a16:creationId xmlns:a16="http://schemas.microsoft.com/office/drawing/2014/main" id="{A16DF191-8A3F-4403-966A-2A86BF7B790B}"/>
+                <a16:creationId xmlns:a16="http://schemas.microsoft.com/office/drawing/2014/main" id="{D499E2F3-7536-4077-B8B3-D222B67B0772}"/>
               </a:ext>
             </a:extLst>
           </p:cNvPr>
@@ -4503,7 +4980,7 @@
                 <a:ea typeface="Aptos"/>
                 <a:cs typeface="Aptos"/>
               </a:rPr>
-              <a:t>IBM Bob inside the investigation loop</a:t>
+              <a:t>Bob probes and repairs the interaction</a:t>
             </a:r>
           </a:p>
         </p:txBody>
@@ -4513,7 +4990,7 @@
           <p:cNvPr id="4" name="">
             <a:extLst xmlns:a="http://schemas.openxmlformats.org/drawingml/2006/main">
               <a:ext uri="{FF2B5EF4-FFF2-40B4-BE49-F238E27FC236}">
-                <a16:creationId xmlns:a16="http://schemas.microsoft.com/office/drawing/2014/main" id="{A51F2EB7-8B82-4E32-BF6B-B4A2624AF2D8}"/>
+                <a16:creationId xmlns:a16="http://schemas.microsoft.com/office/drawing/2014/main" id="{55A5B332-FBF0-4728-B8C7-DEF52D96803A}"/>
               </a:ext>
             </a:extLst>
           </p:cNvPr>
@@ -4560,7 +5037,7 @@
                 <a:ea typeface="Aptos"/>
                 <a:cs typeface="Aptos"/>
               </a:rPr>
-              <a:t>Both relevant task summaries are recorded in bob_sessions/.</a:t>
+              <a:t>Three recorded IBM Bob tasks across two synthetic fixtures.</a:t>
             </a:r>
           </a:p>
         </p:txBody>
@@ -4570,7 +5047,7 @@
           <p:cNvPr id="5" name="">
             <a:extLst xmlns:a="http://schemas.openxmlformats.org/drawingml/2006/main">
               <a:ext uri="{FF2B5EF4-FFF2-40B4-BE49-F238E27FC236}">
-                <a16:creationId xmlns:a16="http://schemas.microsoft.com/office/drawing/2014/main" id="{C8BAF640-496B-4307-A7DF-C99C1C891E30}"/>
+                <a16:creationId xmlns:a16="http://schemas.microsoft.com/office/drawing/2014/main" id="{BB9FFAFA-CECF-4EAF-9112-4CC59C161313}"/>
               </a:ext>
             </a:extLst>
           </p:cNvPr>
@@ -4627,7 +5104,7 @@
           <p:cNvPr id="6" name="">
             <a:extLst xmlns:a="http://schemas.openxmlformats.org/drawingml/2006/main">
               <a:ext uri="{FF2B5EF4-FFF2-40B4-BE49-F238E27FC236}">
-                <a16:creationId xmlns:a16="http://schemas.microsoft.com/office/drawing/2014/main" id="{0E82D96B-7D8F-427D-B7A3-E67FE42EF241}"/>
+                <a16:creationId xmlns:a16="http://schemas.microsoft.com/office/drawing/2014/main" id="{78771D40-05C7-41A2-BFB3-5B4BA179F1D9}"/>
               </a:ext>
             </a:extLst>
           </p:cNvPr>
@@ -4686,7 +5163,7 @@
           <p:cNvPr id="7" name="">
             <a:extLst xmlns:a="http://schemas.openxmlformats.org/drawingml/2006/main">
               <a:ext uri="{FF2B5EF4-FFF2-40B4-BE49-F238E27FC236}">
-                <a16:creationId xmlns:a16="http://schemas.microsoft.com/office/drawing/2014/main" id="{86C4AABD-7D4A-45BE-A31D-7CF8FB1DF867}"/>
+                <a16:creationId xmlns:a16="http://schemas.microsoft.com/office/drawing/2014/main" id="{FF277130-F311-40ED-AE72-F4B8C44CB6AE}"/>
               </a:ext>
             </a:extLst>
           </p:cNvPr>
@@ -4733,7 +5210,7 @@
                 <a:ea typeface="Aptos"/>
                 <a:cs typeface="Aptos"/>
               </a:rPr>
-              <a:t>Task 1: original probe</a:t>
+              <a:t>Bob writes probe</a:t>
             </a:r>
           </a:p>
         </p:txBody>
@@ -4743,7 +5220,7 @@
           <p:cNvPr id="8" name="">
             <a:extLst xmlns:a="http://schemas.openxmlformats.org/drawingml/2006/main">
               <a:ext uri="{FF2B5EF4-FFF2-40B4-BE49-F238E27FC236}">
-                <a16:creationId xmlns:a16="http://schemas.microsoft.com/office/drawing/2014/main" id="{109691BD-DED4-4AB0-9B98-BFD0E1624B04}"/>
+                <a16:creationId xmlns:a16="http://schemas.microsoft.com/office/drawing/2014/main" id="{BED8C1BA-0914-40EA-A1F9-15BAB34D92EB}"/>
               </a:ext>
             </a:extLst>
           </p:cNvPr>
@@ -4790,7 +5267,7 @@
                 <a:ea typeface="Aptos"/>
                 <a:cs typeface="Aptos"/>
               </a:rPr>
-              <a:t>fad890dd…bf59f  |  0.953 Bobcoins</a:t>
+              <a:t>Alpha then Beta on one SKU</a:t>
             </a:r>
           </a:p>
         </p:txBody>
@@ -4800,7 +5277,7 @@
           <p:cNvPr id="9" name="">
             <a:extLst xmlns:a="http://schemas.openxmlformats.org/drawingml/2006/main">
               <a:ext uri="{FF2B5EF4-FFF2-40B4-BE49-F238E27FC236}">
-                <a16:creationId xmlns:a16="http://schemas.microsoft.com/office/drawing/2014/main" id="{31105B90-002D-4A31-A335-4CBB0C2964C0}"/>
+                <a16:creationId xmlns:a16="http://schemas.microsoft.com/office/drawing/2014/main" id="{92146CC6-CA91-4A46-B1B0-0978691F9A1E}"/>
               </a:ext>
             </a:extLst>
           </p:cNvPr>
@@ -4831,7 +5308,7 @@
           <p:cNvPr id="10" name="">
             <a:extLst xmlns:a="http://schemas.openxmlformats.org/drawingml/2006/main">
               <a:ext uri="{FF2B5EF4-FFF2-40B4-BE49-F238E27FC236}">
-                <a16:creationId xmlns:a16="http://schemas.microsoft.com/office/drawing/2014/main" id="{BC1F294D-510D-4BDF-B644-D60E3C36F24B}"/>
+                <a16:creationId xmlns:a16="http://schemas.microsoft.com/office/drawing/2014/main" id="{D528D006-651B-4F50-8BB0-DDED0D2251A5}"/>
               </a:ext>
             </a:extLst>
           </p:cNvPr>
@@ -4890,7 +5367,7 @@
           <p:cNvPr id="11" name="">
             <a:extLst xmlns:a="http://schemas.openxmlformats.org/drawingml/2006/main">
               <a:ext uri="{FF2B5EF4-FFF2-40B4-BE49-F238E27FC236}">
-                <a16:creationId xmlns:a16="http://schemas.microsoft.com/office/drawing/2014/main" id="{17FE7A43-4055-4DDA-8710-C4E84088366C}"/>
+                <a16:creationId xmlns:a16="http://schemas.microsoft.com/office/drawing/2014/main" id="{A009963B-8F5E-4BDB-9D1A-19A4AEDE5C61}"/>
               </a:ext>
             </a:extLst>
           </p:cNvPr>
@@ -4937,7 +5414,7 @@
                 <a:ea typeface="Aptos"/>
                 <a:cs typeface="Aptos"/>
               </a:rPr>
-              <a:t>Audit derivatives</a:t>
+              <a:t>Compare snapshots</a:t>
             </a:r>
           </a:p>
         </p:txBody>
@@ -4947,7 +5424,7 @@
           <p:cNvPr id="12" name="">
             <a:extLst xmlns:a="http://schemas.openxmlformats.org/drawingml/2006/main">
               <a:ext uri="{FF2B5EF4-FFF2-40B4-BE49-F238E27FC236}">
-                <a16:creationId xmlns:a16="http://schemas.microsoft.com/office/drawing/2014/main" id="{BA50AFA1-F9BF-451F-B4AB-DCA9191B329B}"/>
+                <a16:creationId xmlns:a16="http://schemas.microsoft.com/office/drawing/2014/main" id="{16E042D7-58EB-4128-8C3B-8669E498C433}"/>
               </a:ext>
             </a:extLst>
           </p:cNvPr>
@@ -4994,7 +5471,7 @@
                 <a:ea typeface="Aptos"/>
                 <a:cs typeface="Aptos"/>
               </a:rPr>
-              <a:t>Independent strengthened checks</a:t>
+              <a:t>Four states reveal 100 vs 90</a:t>
             </a:r>
           </a:p>
         </p:txBody>
@@ -5004,7 +5481,7 @@
           <p:cNvPr id="13" name="">
             <a:extLst xmlns:a="http://schemas.openxmlformats.org/drawingml/2006/main">
               <a:ext uri="{FF2B5EF4-FFF2-40B4-BE49-F238E27FC236}">
-                <a16:creationId xmlns:a16="http://schemas.microsoft.com/office/drawing/2014/main" id="{C6D85D70-CC82-4528-8587-76C412D4B2AB}"/>
+                <a16:creationId xmlns:a16="http://schemas.microsoft.com/office/drawing/2014/main" id="{91DDDA5E-6A9D-4795-803C-A0B40DBD9BCE}"/>
               </a:ext>
             </a:extLst>
           </p:cNvPr>
@@ -5035,7 +5512,7 @@
           <p:cNvPr id="14" name="">
             <a:extLst xmlns:a="http://schemas.openxmlformats.org/drawingml/2006/main">
               <a:ext uri="{FF2B5EF4-FFF2-40B4-BE49-F238E27FC236}">
-                <a16:creationId xmlns:a16="http://schemas.microsoft.com/office/drawing/2014/main" id="{163AD0A8-D367-467A-ACCA-5FC1B5BBCCFE}"/>
+                <a16:creationId xmlns:a16="http://schemas.microsoft.com/office/drawing/2014/main" id="{1175C377-C51F-4CF4-9E5D-7876A099222C}"/>
               </a:ext>
             </a:extLst>
           </p:cNvPr>
@@ -5094,7 +5571,7 @@
           <p:cNvPr id="15" name="">
             <a:extLst xmlns:a="http://schemas.openxmlformats.org/drawingml/2006/main">
               <a:ext uri="{FF2B5EF4-FFF2-40B4-BE49-F238E27FC236}">
-                <a16:creationId xmlns:a16="http://schemas.microsoft.com/office/drawing/2014/main" id="{6968A661-51AF-497E-8DFE-C783D82073F9}"/>
+                <a16:creationId xmlns:a16="http://schemas.microsoft.com/office/drawing/2014/main" id="{82CD9281-D36C-489C-9EA6-DCE017EC82A6}"/>
               </a:ext>
             </a:extLst>
           </p:cNvPr>
@@ -5141,7 +5618,7 @@
                 <a:ea typeface="Aptos"/>
                 <a:cs typeface="Aptos"/>
               </a:rPr>
-              <a:t>Task 2: repair</a:t>
+              <a:t>Bob writes repair</a:t>
             </a:r>
           </a:p>
         </p:txBody>
@@ -5151,7 +5628,7 @@
           <p:cNvPr id="16" name="">
             <a:extLst xmlns:a="http://schemas.openxmlformats.org/drawingml/2006/main">
               <a:ext uri="{FF2B5EF4-FFF2-40B4-BE49-F238E27FC236}">
-                <a16:creationId xmlns:a16="http://schemas.microsoft.com/office/drawing/2014/main" id="{3D61940B-A9C5-4378-8363-9EE249AFEE7F}"/>
+                <a16:creationId xmlns:a16="http://schemas.microsoft.com/office/drawing/2014/main" id="{2B82BC03-B0A3-48C5-ABBD-000EE0B3CDBE}"/>
               </a:ext>
             </a:extLst>
           </p:cNvPr>
@@ -5198,7 +5675,7 @@
                 <a:ea typeface="Aptos"/>
                 <a:cs typeface="Aptos"/>
               </a:rPr>
-              <a:t>Bob-authored nested-Map repair</a:t>
+              <a:t>Cache by tenant and SKU</a:t>
             </a:r>
           </a:p>
         </p:txBody>
@@ -5208,7 +5685,7 @@
           <p:cNvPr id="17" name="">
             <a:extLst xmlns:a="http://schemas.openxmlformats.org/drawingml/2006/main">
               <a:ext uri="{FF2B5EF4-FFF2-40B4-BE49-F238E27FC236}">
-                <a16:creationId xmlns:a16="http://schemas.microsoft.com/office/drawing/2014/main" id="{640FC38C-3EE9-4E17-B76F-1A9BF50E66AE}"/>
+                <a16:creationId xmlns:a16="http://schemas.microsoft.com/office/drawing/2014/main" id="{1F7335E2-11F3-4075-8CBB-57EDDC4C21CF}"/>
               </a:ext>
             </a:extLst>
           </p:cNvPr>
@@ -5239,7 +5716,7 @@
           <p:cNvPr id="18" name="">
             <a:extLst xmlns:a="http://schemas.openxmlformats.org/drawingml/2006/main">
               <a:ext uri="{FF2B5EF4-FFF2-40B4-BE49-F238E27FC236}">
-                <a16:creationId xmlns:a16="http://schemas.microsoft.com/office/drawing/2014/main" id="{ADA0D0E7-CD40-431B-8427-D9D9F9655110}"/>
+                <a16:creationId xmlns:a16="http://schemas.microsoft.com/office/drawing/2014/main" id="{2EF19384-3D18-4BD0-8F36-5388825C8ACF}"/>
               </a:ext>
             </a:extLst>
           </p:cNvPr>
@@ -5298,7 +5775,7 @@
           <p:cNvPr id="19" name="">
             <a:extLst xmlns:a="http://schemas.openxmlformats.org/drawingml/2006/main">
               <a:ext uri="{FF2B5EF4-FFF2-40B4-BE49-F238E27FC236}">
-                <a16:creationId xmlns:a16="http://schemas.microsoft.com/office/drawing/2014/main" id="{F187E0DA-3682-49BD-9C87-E25FB31A27C2}"/>
+                <a16:creationId xmlns:a16="http://schemas.microsoft.com/office/drawing/2014/main" id="{AE99D5E8-BDDD-4492-A499-644029B68CE9}"/>
               </a:ext>
             </a:extLst>
           </p:cNvPr>
@@ -5345,7 +5822,7 @@
                 <a:ea typeface="Aptos"/>
                 <a:cs typeface="Aptos"/>
               </a:rPr>
-              <a:t>Task 2 evidence</a:t>
+              <a:t>Independent audit</a:t>
             </a:r>
           </a:p>
         </p:txBody>
@@ -5355,7 +5832,7 @@
           <p:cNvPr id="20" name="">
             <a:extLst xmlns:a="http://schemas.openxmlformats.org/drawingml/2006/main">
               <a:ext uri="{FF2B5EF4-FFF2-40B4-BE49-F238E27FC236}">
-                <a16:creationId xmlns:a16="http://schemas.microsoft.com/office/drawing/2014/main" id="{1BD46959-2EA7-404E-843E-99A8C3CD3E06}"/>
+                <a16:creationId xmlns:a16="http://schemas.microsoft.com/office/drawing/2014/main" id="{25542D69-743A-4467-9AB6-7CBC82C5ECC4}"/>
               </a:ext>
             </a:extLst>
           </p:cNvPr>
@@ -5402,7 +5879,7 @@
                 <a:ea typeface="Aptos"/>
                 <a:cs typeface="Aptos"/>
               </a:rPr>
-              <a:t>d093059…6c74  |  0.637 Bobcoins</a:t>
+              <a:t>Frozen probe and feature checks</a:t>
             </a:r>
           </a:p>
         </p:txBody>
@@ -5412,7 +5889,7 @@
           <p:cNvPr id="21" name="">
             <a:extLst xmlns:a="http://schemas.openxmlformats.org/drawingml/2006/main">
               <a:ext uri="{FF2B5EF4-FFF2-40B4-BE49-F238E27FC236}">
-                <a16:creationId xmlns:a16="http://schemas.microsoft.com/office/drawing/2014/main" id="{17428DC6-F88E-4233-B46C-4251EE4ECC09}"/>
+                <a16:creationId xmlns:a16="http://schemas.microsoft.com/office/drawing/2014/main" id="{94754D37-210F-4622-9692-363069D8F645}"/>
               </a:ext>
             </a:extLst>
           </p:cNvPr>
@@ -5445,25 +5922,25 @@
           <a:lstStyle xmlns:a="http://schemas.openxmlformats.org/drawingml/2006/main"/>
           <a:p xmlns:a="http://schemas.openxmlformats.org/drawingml/2006/main">
             <a:pPr>
-              <a:defRPr sz="1425" b="0">
-                <a:solidFill>
-                  <a:srgbClr val="F8FBFF"/>
-                </a:solidFill>
-                <a:latin typeface="Aptos"/>
-                <a:ea typeface="Aptos"/>
-                <a:cs typeface="Aptos"/>
-              </a:defRPr>
-            </a:pPr>
-            <a:r>
-              <a:rPr sz="1425" b="0">
-                <a:solidFill>
-                  <a:srgbClr val="F8FBFF"/>
-                </a:solidFill>
-                <a:latin typeface="Aptos"/>
-                <a:ea typeface="Aptos"/>
-                <a:cs typeface="Aptos"/>
-              </a:rPr>
-              <a:t>Recorded: 01-tenant-cache-probe-summary.png and 02-tenant-cache-repair-summary.png in bob_sessions/.</a:t>
+              <a:defRPr sz="1575" b="0">
+                <a:solidFill>
+                  <a:srgbClr val="F8FBFF"/>
+                </a:solidFill>
+                <a:latin typeface="Aptos"/>
+                <a:ea typeface="Aptos"/>
+                <a:cs typeface="Aptos"/>
+              </a:defRPr>
+            </a:pPr>
+            <a:r>
+              <a:rPr sz="1575" b="0">
+                <a:solidFill>
+                  <a:srgbClr val="F8FBFF"/>
+                </a:solidFill>
+                <a:latin typeface="Aptos"/>
+                <a:ea typeface="Aptos"/>
+                <a:cs typeface="Aptos"/>
+              </a:rPr>
+              <a:t>3 Bob sessions recorded. Second scenario: priority/cursor probe, combined fails 3/3.</a:t>
             </a:r>
           </a:p>
         </p:txBody>
@@ -5471,7 +5948,7 @@
     </p:spTree>
     <p:extLst>
       <p:ext uri="{BB962C8B-B14F-4D97-AF65-F5344CB8AC3E}">
-        <p14:creationId xmlns:p14="http://schemas.microsoft.com/office/powerpoint/2010/main" val="961796077"/>
+        <p14:creationId xmlns:p14="http://schemas.microsoft.com/office/powerpoint/2010/main" val="1581312385"/>
       </p:ext>
     </p:extLst>
   </p:cSld>
@@ -5502,7 +5979,7 @@
           <p:cNvPr id="22" name="">
             <a:extLst xmlns:a="http://schemas.openxmlformats.org/drawingml/2006/main">
               <a:ext uri="{FF2B5EF4-FFF2-40B4-BE49-F238E27FC236}">
-                <a16:creationId xmlns:a16="http://schemas.microsoft.com/office/drawing/2014/main" id="{159E4152-DBAC-48C7-8714-CB45FF42BAA5}"/>
+                <a16:creationId xmlns:a16="http://schemas.microsoft.com/office/drawing/2014/main" id="{6A6804C1-B343-4639-BAD4-BE48FF4551B1}"/>
               </a:ext>
             </a:extLst>
           </p:cNvPr>
@@ -5532,7 +6009,7 @@
           <p:cNvPr id="2" name="">
             <a:extLst xmlns:a="http://schemas.openxmlformats.org/drawingml/2006/main">
               <a:ext uri="{FF2B5EF4-FFF2-40B4-BE49-F238E27FC236}">
-                <a16:creationId xmlns:a16="http://schemas.microsoft.com/office/drawing/2014/main" id="{AB5B2301-0BF7-48A6-AEE4-963DA699B7A6}"/>
+                <a16:creationId xmlns:a16="http://schemas.microsoft.com/office/drawing/2014/main" id="{0790CA5C-79A2-461A-B8DB-AB1401CF90E1}"/>
               </a:ext>
             </a:extLst>
           </p:cNvPr>
@@ -5589,7 +6066,7 @@
           <p:cNvPr id="3" name="">
             <a:extLst xmlns:a="http://schemas.openxmlformats.org/drawingml/2006/main">
               <a:ext uri="{FF2B5EF4-FFF2-40B4-BE49-F238E27FC236}">
-                <a16:creationId xmlns:a16="http://schemas.microsoft.com/office/drawing/2014/main" id="{A4156840-6408-49D4-82D9-C81B9FEFAF44}"/>
+                <a16:creationId xmlns:a16="http://schemas.microsoft.com/office/drawing/2014/main" id="{4AD285E9-3BEB-40F9-B748-238CB40BAE01}"/>
               </a:ext>
             </a:extLst>
           </p:cNvPr>
@@ -5646,7 +6123,7 @@
           <p:cNvPr id="4" name="">
             <a:extLst xmlns:a="http://schemas.openxmlformats.org/drawingml/2006/main">
               <a:ext uri="{FF2B5EF4-FFF2-40B4-BE49-F238E27FC236}">
-                <a16:creationId xmlns:a16="http://schemas.microsoft.com/office/drawing/2014/main" id="{095C8B9E-ACB2-49D7-B7B6-1C979188EE90}"/>
+                <a16:creationId xmlns:a16="http://schemas.microsoft.com/office/drawing/2014/main" id="{F11AE42E-A3C6-4130-8D4F-412F17D3CC22}"/>
               </a:ext>
             </a:extLst>
           </p:cNvPr>
@@ -5703,7 +6180,7 @@
           <p:cNvPr id="5" name="">
             <a:extLst xmlns:a="http://schemas.openxmlformats.org/drawingml/2006/main">
               <a:ext uri="{FF2B5EF4-FFF2-40B4-BE49-F238E27FC236}">
-                <a16:creationId xmlns:a16="http://schemas.microsoft.com/office/drawing/2014/main" id="{CE9D09C8-E3EA-4B80-871F-50E08F8B3DF3}"/>
+                <a16:creationId xmlns:a16="http://schemas.microsoft.com/office/drawing/2014/main" id="{F341BDF5-E1D3-49BE-AD5B-3E2A5B9A23EE}"/>
               </a:ext>
             </a:extLst>
           </p:cNvPr>
@@ -5760,7 +6237,7 @@
           <p:cNvPr id="6" name="">
             <a:extLst xmlns:a="http://schemas.openxmlformats.org/drawingml/2006/main">
               <a:ext uri="{FF2B5EF4-FFF2-40B4-BE49-F238E27FC236}">
-                <a16:creationId xmlns:a16="http://schemas.microsoft.com/office/drawing/2014/main" id="{65D452D1-1DC0-4AEA-97F1-9C956AA7E4DD}"/>
+                <a16:creationId xmlns:a16="http://schemas.microsoft.com/office/drawing/2014/main" id="{EA9E5EF2-A5CD-4EEE-87DA-012567078CCB}"/>
               </a:ext>
             </a:extLst>
           </p:cNvPr>
@@ -5880,7 +6357,7 @@
           <p:cNvPr id="7" name="">
             <a:extLst xmlns:a="http://schemas.openxmlformats.org/drawingml/2006/main">
               <a:ext uri="{FF2B5EF4-FFF2-40B4-BE49-F238E27FC236}">
-                <a16:creationId xmlns:a16="http://schemas.microsoft.com/office/drawing/2014/main" id="{87B93BE7-5956-4863-A92C-4C9A64AE4C1A}"/>
+                <a16:creationId xmlns:a16="http://schemas.microsoft.com/office/drawing/2014/main" id="{DE894EE4-FDB4-44E9-B71F-B61C9440E07B}"/>
               </a:ext>
             </a:extLst>
           </p:cNvPr>
@@ -6000,7 +6477,7 @@
           <p:cNvPr id="8" name="">
             <a:extLst xmlns:a="http://schemas.openxmlformats.org/drawingml/2006/main">
               <a:ext uri="{FF2B5EF4-FFF2-40B4-BE49-F238E27FC236}">
-                <a16:creationId xmlns:a16="http://schemas.microsoft.com/office/drawing/2014/main" id="{3CE1428D-9DE0-4130-AC6A-2253BAF2ECD4}"/>
+                <a16:creationId xmlns:a16="http://schemas.microsoft.com/office/drawing/2014/main" id="{B6F36288-135E-40F3-954B-B1A47EFC0556}"/>
               </a:ext>
             </a:extLst>
           </p:cNvPr>
@@ -6031,19 +6508,19 @@
           <p:cNvPr id="9" name="">
             <a:extLst xmlns:a="http://schemas.openxmlformats.org/drawingml/2006/main">
               <a:ext uri="{FF2B5EF4-FFF2-40B4-BE49-F238E27FC236}">
-                <a16:creationId xmlns:a16="http://schemas.microsoft.com/office/drawing/2014/main" id="{785F8ED2-9D95-448C-A196-8AB2ADE2C856}"/>
-              </a:ext>
-            </a:extLst>
-          </p:cNvPr>
-          <p:cNvSpPr>
-            <a:spLocks xmlns:a="http://schemas.openxmlformats.org/drawingml/2006/main" noGrp="1"/>
-          </p:cNvSpPr>
-          <p:nvPr/>
-        </p:nvSpPr>
-        <p:spPr>
-          <a:xfrm xmlns:a="http://schemas.openxmlformats.org/drawingml/2006/main">
-            <a:off x="5391150" y="3105150"/>
-            <a:ext cx="457200" cy="457200"/>
+                <a16:creationId xmlns:a16="http://schemas.microsoft.com/office/drawing/2014/main" id="{3C1CC5A2-87F2-4BB7-BFAA-3D64FB1A4221}"/>
+              </a:ext>
+            </a:extLst>
+          </p:cNvPr>
+          <p:cNvSpPr>
+            <a:spLocks xmlns:a="http://schemas.openxmlformats.org/drawingml/2006/main" noGrp="1"/>
+          </p:cNvSpPr>
+          <p:nvPr/>
+        </p:nvSpPr>
+        <p:spPr>
+          <a:xfrm xmlns:a="http://schemas.openxmlformats.org/drawingml/2006/main">
+            <a:off x="5238750" y="3067050"/>
+            <a:ext cx="762000" cy="571500"/>
           </a:xfrm>
           <a:prstGeom xmlns:a="http://schemas.openxmlformats.org/drawingml/2006/main" prst="ellipse">
             <a:avLst/>
@@ -6057,12 +6534,12 @@
         </p:spPr>
         <p:txBody>
           <a:bodyPr xmlns:a="http://schemas.openxmlformats.org/drawingml/2006/main">
-            <a:normAutofit fontScale="78016"/>
-          </a:bodyPr>
-          <a:lstStyle xmlns:a="http://schemas.openxmlformats.org/drawingml/2006/main"/>
-          <a:p xmlns:a="http://schemas.openxmlformats.org/drawingml/2006/main">
-            <a:pPr>
-              <a:defRPr sz="1950" b="1">
+            <a:normAutofit fontScale="100000"/>
+          </a:bodyPr>
+          <a:lstStyle xmlns:a="http://schemas.openxmlformats.org/drawingml/2006/main"/>
+          <a:p xmlns:a="http://schemas.openxmlformats.org/drawingml/2006/main">
+            <a:pPr>
+              <a:defRPr sz="1275" b="1">
                 <a:solidFill>
                   <a:srgbClr val="081B33"/>
                 </a:solidFill>
@@ -6072,7 +6549,7 @@
               </a:defRPr>
             </a:pPr>
             <a:r>
-              <a:rPr sz="1950" b="1">
+              <a:rPr sz="1275" b="1">
                 <a:solidFill>
                   <a:srgbClr val="081B33"/>
                 </a:solidFill>
@@ -6080,7 +6557,7 @@
                 <a:ea typeface="Aptos"/>
                 <a:cs typeface="Aptos"/>
               </a:rPr>
-              <a:t>?</a:t>
+              <a:t>BOB</a:t>
             </a:r>
           </a:p>
         </p:txBody>
@@ -6090,7 +6567,7 @@
           <p:cNvPr id="10" name="">
             <a:extLst xmlns:a="http://schemas.openxmlformats.org/drawingml/2006/main">
               <a:ext uri="{FF2B5EF4-FFF2-40B4-BE49-F238E27FC236}">
-                <a16:creationId xmlns:a16="http://schemas.microsoft.com/office/drawing/2014/main" id="{AADB1206-1AC2-4B04-AEBD-070CB5C9CE4A}"/>
+                <a16:creationId xmlns:a16="http://schemas.microsoft.com/office/drawing/2014/main" id="{80FEFEAB-7F77-42B5-823E-F798916792D5}"/>
               </a:ext>
             </a:extLst>
           </p:cNvPr>
@@ -6125,7 +6602,7 @@
           <p:cNvPr id="11" name="">
             <a:extLst xmlns:a="http://schemas.openxmlformats.org/drawingml/2006/main">
               <a:ext uri="{FF2B5EF4-FFF2-40B4-BE49-F238E27FC236}">
-                <a16:creationId xmlns:a16="http://schemas.microsoft.com/office/drawing/2014/main" id="{BE04AA47-EC2A-412A-9EAE-36E77A2FE483}"/>
+                <a16:creationId xmlns:a16="http://schemas.microsoft.com/office/drawing/2014/main" id="{D40015FB-ACF7-4D95-9637-6AE57C667522}"/>
               </a:ext>
             </a:extLst>
           </p:cNvPr>
@@ -6182,7 +6659,7 @@
           <p:cNvPr id="12" name="">
             <a:extLst xmlns:a="http://schemas.openxmlformats.org/drawingml/2006/main">
               <a:ext uri="{FF2B5EF4-FFF2-40B4-BE49-F238E27FC236}">
-                <a16:creationId xmlns:a16="http://schemas.microsoft.com/office/drawing/2014/main" id="{952E7D78-C2CD-4463-8360-D41F32C2CAE7}"/>
+                <a16:creationId xmlns:a16="http://schemas.microsoft.com/office/drawing/2014/main" id="{9A8EF76E-FC09-4CA9-BFCC-BD961834565D}"/>
               </a:ext>
             </a:extLst>
           </p:cNvPr>
@@ -6212,7 +6689,7 @@
           <p:cNvPr id="13" name="">
             <a:extLst xmlns:a="http://schemas.openxmlformats.org/drawingml/2006/main">
               <a:ext uri="{FF2B5EF4-FFF2-40B4-BE49-F238E27FC236}">
-                <a16:creationId xmlns:a16="http://schemas.microsoft.com/office/drawing/2014/main" id="{A53D940A-6585-4BB2-8164-6C0433F1B3BD}"/>
+                <a16:creationId xmlns:a16="http://schemas.microsoft.com/office/drawing/2014/main" id="{A360403E-928B-4B42-B582-797D11A2ABDC}"/>
               </a:ext>
             </a:extLst>
           </p:cNvPr>
@@ -6269,7 +6746,7 @@
           <p:cNvPr id="14" name="">
             <a:extLst xmlns:a="http://schemas.openxmlformats.org/drawingml/2006/main">
               <a:ext uri="{FF2B5EF4-FFF2-40B4-BE49-F238E27FC236}">
-                <a16:creationId xmlns:a16="http://schemas.microsoft.com/office/drawing/2014/main" id="{C53C9C37-EF5D-4536-A555-19AA2BE1AC6B}"/>
+                <a16:creationId xmlns:a16="http://schemas.microsoft.com/office/drawing/2014/main" id="{91078358-A0D3-4462-BF21-31391C4B14E6}"/>
               </a:ext>
             </a:extLst>
           </p:cNvPr>
@@ -6304,7 +6781,7 @@
           <p:cNvPr id="15" name="">
             <a:extLst xmlns:a="http://schemas.openxmlformats.org/drawingml/2006/main">
               <a:ext uri="{FF2B5EF4-FFF2-40B4-BE49-F238E27FC236}">
-                <a16:creationId xmlns:a16="http://schemas.microsoft.com/office/drawing/2014/main" id="{430B161F-A562-48BC-BA87-FDD2FD8D59EC}"/>
+                <a16:creationId xmlns:a16="http://schemas.microsoft.com/office/drawing/2014/main" id="{F7335765-ACDA-4C06-AFCD-98044E8A3295}"/>
               </a:ext>
             </a:extLst>
           </p:cNvPr>
@@ -6361,7 +6838,7 @@
           <p:cNvPr id="16" name="">
             <a:extLst xmlns:a="http://schemas.openxmlformats.org/drawingml/2006/main">
               <a:ext uri="{FF2B5EF4-FFF2-40B4-BE49-F238E27FC236}">
-                <a16:creationId xmlns:a16="http://schemas.microsoft.com/office/drawing/2014/main" id="{FAB2F1DA-D5CF-469F-8711-58C383B76B2F}"/>
+                <a16:creationId xmlns:a16="http://schemas.microsoft.com/office/drawing/2014/main" id="{7329E896-5828-4D60-A505-215A97BD934F}"/>
               </a:ext>
             </a:extLst>
           </p:cNvPr>
@@ -6391,7 +6868,7 @@
           <p:cNvPr id="17" name="">
             <a:extLst xmlns:a="http://schemas.openxmlformats.org/drawingml/2006/main">
               <a:ext uri="{FF2B5EF4-FFF2-40B4-BE49-F238E27FC236}">
-                <a16:creationId xmlns:a16="http://schemas.microsoft.com/office/drawing/2014/main" id="{9F1F502A-AEA8-4CE1-B1ED-459786C7A6C1}"/>
+                <a16:creationId xmlns:a16="http://schemas.microsoft.com/office/drawing/2014/main" id="{4202384A-6441-44CC-B702-287A4167CB9D}"/>
               </a:ext>
             </a:extLst>
           </p:cNvPr>
@@ -6448,7 +6925,7 @@
           <p:cNvPr id="18" name="">
             <a:extLst xmlns:a="http://schemas.openxmlformats.org/drawingml/2006/main">
               <a:ext uri="{FF2B5EF4-FFF2-40B4-BE49-F238E27FC236}">
-                <a16:creationId xmlns:a16="http://schemas.microsoft.com/office/drawing/2014/main" id="{4147717C-5D11-491F-9590-0601D7985D78}"/>
+                <a16:creationId xmlns:a16="http://schemas.microsoft.com/office/drawing/2014/main" id="{2FBFC7DE-5A24-4B00-A86F-0A0867151C85}"/>
               </a:ext>
             </a:extLst>
           </p:cNvPr>
@@ -6483,7 +6960,7 @@
           <p:cNvPr id="19" name="">
             <a:extLst xmlns:a="http://schemas.openxmlformats.org/drawingml/2006/main">
               <a:ext uri="{FF2B5EF4-FFF2-40B4-BE49-F238E27FC236}">
-                <a16:creationId xmlns:a16="http://schemas.microsoft.com/office/drawing/2014/main" id="{8541240E-6DEA-4DD7-A280-F5BA4C47C612}"/>
+                <a16:creationId xmlns:a16="http://schemas.microsoft.com/office/drawing/2014/main" id="{004C1BBB-2629-470F-8872-77B52F79FDD9}"/>
               </a:ext>
             </a:extLst>
           </p:cNvPr>
@@ -6540,7 +7017,7 @@
           <p:cNvPr id="20" name="">
             <a:extLst xmlns:a="http://schemas.openxmlformats.org/drawingml/2006/main">
               <a:ext uri="{FF2B5EF4-FFF2-40B4-BE49-F238E27FC236}">
-                <a16:creationId xmlns:a16="http://schemas.microsoft.com/office/drawing/2014/main" id="{DB7327C8-E054-46B3-9FA0-30926F3B37A1}"/>
+                <a16:creationId xmlns:a16="http://schemas.microsoft.com/office/drawing/2014/main" id="{48A8978D-7B46-45A4-BC91-5FF16EC53D8D}"/>
               </a:ext>
             </a:extLst>
           </p:cNvPr>
@@ -6570,7 +7047,7 @@
           <p:cNvPr id="21" name="">
             <a:extLst xmlns:a="http://schemas.openxmlformats.org/drawingml/2006/main">
               <a:ext uri="{FF2B5EF4-FFF2-40B4-BE49-F238E27FC236}">
-                <a16:creationId xmlns:a16="http://schemas.microsoft.com/office/drawing/2014/main" id="{B7E41104-3FFA-4F05-82C6-68D3505E8D5B}"/>
+                <a16:creationId xmlns:a16="http://schemas.microsoft.com/office/drawing/2014/main" id="{7E59C1FF-5A53-4FF5-9CEF-C930422C485D}"/>
               </a:ext>
             </a:extLst>
           </p:cNvPr>
@@ -6625,7 +7102,7 @@
     </p:spTree>
     <p:extLst>
       <p:ext uri="{BB962C8B-B14F-4D97-AF65-F5344CB8AC3E}">
-        <p14:creationId xmlns:p14="http://schemas.microsoft.com/office/powerpoint/2010/main" val="1990342056"/>
+        <p14:creationId xmlns:p14="http://schemas.microsoft.com/office/powerpoint/2010/main" val="513868718"/>
       </p:ext>
     </p:extLst>
   </p:cSld>
@@ -6653,10 +7130,10 @@
       </p:grpSpPr>
       <p:sp>
         <p:nvSpPr>
-          <p:cNvPr id="13" name="">
-            <a:extLst xmlns:a="http://schemas.openxmlformats.org/drawingml/2006/main">
-              <a:ext uri="{FF2B5EF4-FFF2-40B4-BE49-F238E27FC236}">
-                <a16:creationId xmlns:a16="http://schemas.microsoft.com/office/drawing/2014/main" id="{B9DB6E5D-75B0-42B1-9BED-0D8F5F9850B5}"/>
+          <p:cNvPr id="14" name="">
+            <a:extLst xmlns:a="http://schemas.openxmlformats.org/drawingml/2006/main">
+              <a:ext uri="{FF2B5EF4-FFF2-40B4-BE49-F238E27FC236}">
+                <a16:creationId xmlns:a16="http://schemas.microsoft.com/office/drawing/2014/main" id="{6F501A8E-5FAB-48B6-96F1-261CD5DE6D6D}"/>
               </a:ext>
             </a:extLst>
           </p:cNvPr>
@@ -6686,7 +7163,7 @@
           <p:cNvPr id="2" name="">
             <a:extLst xmlns:a="http://schemas.openxmlformats.org/drawingml/2006/main">
               <a:ext uri="{FF2B5EF4-FFF2-40B4-BE49-F238E27FC236}">
-                <a16:creationId xmlns:a16="http://schemas.microsoft.com/office/drawing/2014/main" id="{73530617-2F73-4205-AF48-82EF199AFDE3}"/>
+                <a16:creationId xmlns:a16="http://schemas.microsoft.com/office/drawing/2014/main" id="{BE18D04C-5D84-42F3-A132-ABD0D2EAB2CC}"/>
               </a:ext>
             </a:extLst>
           </p:cNvPr>
@@ -6743,7 +7220,7 @@
           <p:cNvPr id="3" name="">
             <a:extLst xmlns:a="http://schemas.openxmlformats.org/drawingml/2006/main">
               <a:ext uri="{FF2B5EF4-FFF2-40B4-BE49-F238E27FC236}">
-                <a16:creationId xmlns:a16="http://schemas.microsoft.com/office/drawing/2014/main" id="{A0C56D27-E5B4-4CE9-A8B1-5CAF3D6189A7}"/>
+                <a16:creationId xmlns:a16="http://schemas.microsoft.com/office/drawing/2014/main" id="{BA5709E8-2A62-4A96-B0A8-A93AC5C0C333}"/>
               </a:ext>
             </a:extLst>
           </p:cNvPr>
@@ -6800,7 +7277,7 @@
           <p:cNvPr id="4" name="">
             <a:extLst xmlns:a="http://schemas.openxmlformats.org/drawingml/2006/main">
               <a:ext uri="{FF2B5EF4-FFF2-40B4-BE49-F238E27FC236}">
-                <a16:creationId xmlns:a16="http://schemas.microsoft.com/office/drawing/2014/main" id="{2FB205B9-6216-40DD-98F1-4C8BAA9E83BA}"/>
+                <a16:creationId xmlns:a16="http://schemas.microsoft.com/office/drawing/2014/main" id="{E5B5E193-78DD-486B-B5DB-10465293FC53}"/>
               </a:ext>
             </a:extLst>
           </p:cNvPr>
@@ -6857,7 +7334,7 @@
           <p:cNvPr id="5" name="">
             <a:extLst xmlns:a="http://schemas.openxmlformats.org/drawingml/2006/main">
               <a:ext uri="{FF2B5EF4-FFF2-40B4-BE49-F238E27FC236}">
-                <a16:creationId xmlns:a16="http://schemas.microsoft.com/office/drawing/2014/main" id="{FDED3342-D955-4DE4-B92E-C700CDD88612}"/>
+                <a16:creationId xmlns:a16="http://schemas.microsoft.com/office/drawing/2014/main" id="{50ED615F-1F7D-4563-AEA3-8C0EB8CEDE45}"/>
               </a:ext>
             </a:extLst>
           </p:cNvPr>
@@ -6914,7 +7391,7 @@
           <p:cNvPr id="6" name="">
             <a:extLst xmlns:a="http://schemas.openxmlformats.org/drawingml/2006/main">
               <a:ext uri="{FF2B5EF4-FFF2-40B4-BE49-F238E27FC236}">
-                <a16:creationId xmlns:a16="http://schemas.microsoft.com/office/drawing/2014/main" id="{EF877F11-DBD1-4967-8B58-BAD530923535}"/>
+                <a16:creationId xmlns:a16="http://schemas.microsoft.com/office/drawing/2014/main" id="{4E0F9BEE-24B4-47B0-B65F-BD7289BA5654}"/>
               </a:ext>
             </a:extLst>
           </p:cNvPr>
@@ -6950,25 +7427,25 @@
           <a:lstStyle xmlns:a="http://schemas.openxmlformats.org/drawingml/2006/main"/>
           <a:p xmlns:a="http://schemas.openxmlformats.org/drawingml/2006/main">
             <a:pPr>
-              <a:defRPr sz="1875" b="0">
-                <a:solidFill>
-                  <a:srgbClr val="F8FBFF"/>
-                </a:solidFill>
-                <a:latin typeface="Aptos"/>
-                <a:ea typeface="Aptos"/>
-                <a:cs typeface="Aptos"/>
-              </a:defRPr>
-            </a:pPr>
-            <a:r>
-              <a:rPr sz="1875" b="0">
-                <a:solidFill>
-                  <a:srgbClr val="F8FBFF"/>
-                </a:solidFill>
-                <a:latin typeface="Aptos"/>
-                <a:ea typeface="Aptos"/>
-                <a:cs typeface="Aptos"/>
-              </a:rPr>
-              <a:t>Run the laboratory</a:t>
+              <a:defRPr sz="1800" b="0">
+                <a:solidFill>
+                  <a:srgbClr val="F8FBFF"/>
+                </a:solidFill>
+                <a:latin typeface="Aptos"/>
+                <a:ea typeface="Aptos"/>
+                <a:cs typeface="Aptos"/>
+              </a:defRPr>
+            </a:pPr>
+            <a:r>
+              <a:rPr sz="1800" b="0">
+                <a:solidFill>
+                  <a:srgbClr val="F8FBFF"/>
+                </a:solidFill>
+                <a:latin typeface="Aptos"/>
+                <a:ea typeface="Aptos"/>
+                <a:cs typeface="Aptos"/>
+              </a:rPr>
+              <a:t>Run the demo</a:t>
             </a:r>
           </a:p>
           <a:p xmlns:a="http://schemas.openxmlformats.org/drawingml/2006/main">
@@ -6978,48 +7455,25 @@
           </a:p>
           <a:p xmlns:a="http://schemas.openxmlformats.org/drawingml/2006/main">
             <a:pPr>
-              <a:defRPr sz="1875" b="0">
-                <a:solidFill>
-                  <a:srgbClr val="F8FBFF"/>
-                </a:solidFill>
-                <a:latin typeface="Aptos"/>
-                <a:ea typeface="Aptos"/>
-                <a:cs typeface="Aptos"/>
-              </a:defRPr>
-            </a:pPr>
-            <a:r>
-              <a:rPr sz="1875" b="0">
-                <a:solidFill>
-                  <a:srgbClr val="F8FBFF"/>
-                </a:solidFill>
-                <a:latin typeface="Aptos"/>
-                <a:ea typeface="Aptos"/>
-                <a:cs typeface="Aptos"/>
-              </a:rPr>
-              <a:t>Inspect the input sequence</a:t>
-            </a:r>
-          </a:p>
-          <a:p xmlns:a="http://schemas.openxmlformats.org/drawingml/2006/main">
-            <a:pPr>
-              <a:defRPr sz="1875" b="0">
-                <a:solidFill>
-                  <a:srgbClr val="F8FBFF"/>
-                </a:solidFill>
-                <a:latin typeface="Aptos"/>
-                <a:ea typeface="Aptos"/>
-                <a:cs typeface="Aptos"/>
-              </a:defRPr>
-            </a:pPr>
-            <a:r>
-              <a:rPr sz="1875" b="0">
-                <a:solidFill>
-                  <a:srgbClr val="F8FBFF"/>
-                </a:solidFill>
-                <a:latin typeface="Aptos"/>
-                <a:ea typeface="Aptos"/>
-                <a:cs typeface="Aptos"/>
-              </a:rPr>
-              <a:t>and the observed result</a:t>
+              <a:defRPr sz="1800" b="0">
+                <a:solidFill>
+                  <a:srgbClr val="F8FBFF"/>
+                </a:solidFill>
+                <a:latin typeface="Aptos"/>
+                <a:ea typeface="Aptos"/>
+                <a:cs typeface="Aptos"/>
+              </a:defRPr>
+            </a:pPr>
+            <a:r>
+              <a:rPr sz="1800" b="0">
+                <a:solidFill>
+                  <a:srgbClr val="F8FBFF"/>
+                </a:solidFill>
+                <a:latin typeface="Aptos"/>
+                <a:ea typeface="Aptos"/>
+                <a:cs typeface="Aptos"/>
+              </a:rPr>
+              <a:t>Compare snapshots and inspect the sequence</a:t>
             </a:r>
           </a:p>
         </p:txBody>
@@ -7029,7 +7483,7 @@
           <p:cNvPr id="7" name="">
             <a:extLst xmlns:a="http://schemas.openxmlformats.org/drawingml/2006/main">
               <a:ext uri="{FF2B5EF4-FFF2-40B4-BE49-F238E27FC236}">
-                <a16:creationId xmlns:a16="http://schemas.microsoft.com/office/drawing/2014/main" id="{62699759-B28F-4649-AF16-F59D2566FE74}"/>
+                <a16:creationId xmlns:a16="http://schemas.microsoft.com/office/drawing/2014/main" id="{968CC582-0A9D-450A-9AB2-B523FE7954C3}"/>
               </a:ext>
             </a:extLst>
           </p:cNvPr>
@@ -7065,17 +7519,17 @@
           <a:lstStyle xmlns:a="http://schemas.openxmlformats.org/drawingml/2006/main"/>
           <a:p xmlns:a="http://schemas.openxmlformats.org/drawingml/2006/main">
             <a:pPr>
-              <a:defRPr sz="1875" b="0">
-                <a:solidFill>
-                  <a:srgbClr val="F8FBFF"/>
-                </a:solidFill>
-                <a:latin typeface="Aptos"/>
-                <a:ea typeface="Aptos"/>
-                <a:cs typeface="Aptos"/>
-              </a:defRPr>
-            </a:pPr>
-            <a:r>
-              <a:rPr sz="1875" b="0">
+              <a:defRPr sz="1800" b="0">
+                <a:solidFill>
+                  <a:srgbClr val="F8FBFF"/>
+                </a:solidFill>
+                <a:latin typeface="Aptos"/>
+                <a:ea typeface="Aptos"/>
+                <a:cs typeface="Aptos"/>
+              </a:defRPr>
+            </a:pPr>
+            <a:r>
+              <a:rPr sz="1800" b="0">
                 <a:solidFill>
                   <a:srgbClr val="F8FBFF"/>
                 </a:solidFill>
@@ -7093,48 +7547,25 @@
           </a:p>
           <a:p xmlns:a="http://schemas.openxmlformats.org/drawingml/2006/main">
             <a:pPr>
-              <a:defRPr sz="1875" b="0">
-                <a:solidFill>
-                  <a:srgbClr val="F8FBFF"/>
-                </a:solidFill>
-                <a:latin typeface="Aptos"/>
-                <a:ea typeface="Aptos"/>
-                <a:cs typeface="Aptos"/>
-              </a:defRPr>
-            </a:pPr>
-            <a:r>
-              <a:rPr sz="1875" b="0">
-                <a:solidFill>
-                  <a:srgbClr val="F8FBFF"/>
-                </a:solidFill>
-                <a:latin typeface="Aptos"/>
-                <a:ea typeface="Aptos"/>
-                <a:cs typeface="Aptos"/>
-              </a:rPr>
-              <a:t>See commits, probe hash,</a:t>
-            </a:r>
-          </a:p>
-          <a:p xmlns:a="http://schemas.openxmlformats.org/drawingml/2006/main">
-            <a:pPr>
-              <a:defRPr sz="1875" b="0">
-                <a:solidFill>
-                  <a:srgbClr val="F8FBFF"/>
-                </a:solidFill>
-                <a:latin typeface="Aptos"/>
-                <a:ea typeface="Aptos"/>
-                <a:cs typeface="Aptos"/>
-              </a:defRPr>
-            </a:pPr>
-            <a:r>
-              <a:rPr sz="1875" b="0">
-                <a:solidFill>
-                  <a:srgbClr val="F8FBFF"/>
-                </a:solidFill>
-                <a:latin typeface="Aptos"/>
-                <a:ea typeface="Aptos"/>
-                <a:cs typeface="Aptos"/>
-              </a:rPr>
-              <a:t>and reproduction commands</a:t>
+              <a:defRPr sz="1800" b="0">
+                <a:solidFill>
+                  <a:srgbClr val="F8FBFF"/>
+                </a:solidFill>
+                <a:latin typeface="Aptos"/>
+                <a:ea typeface="Aptos"/>
+                <a:cs typeface="Aptos"/>
+              </a:defRPr>
+            </a:pPr>
+            <a:r>
+              <a:rPr sz="1800" b="0">
+                <a:solidFill>
+                  <a:srgbClr val="F8FBFF"/>
+                </a:solidFill>
+                <a:latin typeface="Aptos"/>
+                <a:ea typeface="Aptos"/>
+                <a:cs typeface="Aptos"/>
+              </a:rPr>
+              <a:t>Check commits, probe hash and commands</a:t>
             </a:r>
           </a:p>
         </p:txBody>
@@ -7144,7 +7575,7 @@
           <p:cNvPr id="8" name="">
             <a:extLst xmlns:a="http://schemas.openxmlformats.org/drawingml/2006/main">
               <a:ext uri="{FF2B5EF4-FFF2-40B4-BE49-F238E27FC236}">
-                <a16:creationId xmlns:a16="http://schemas.microsoft.com/office/drawing/2014/main" id="{C1E633CD-3413-45B7-A09E-44018D991AD5}"/>
+                <a16:creationId xmlns:a16="http://schemas.microsoft.com/office/drawing/2014/main" id="{B69B1889-A6CB-4D28-868F-12981ACD5900}"/>
               </a:ext>
             </a:extLst>
           </p:cNvPr>
@@ -7180,17 +7611,17 @@
           <a:lstStyle xmlns:a="http://schemas.openxmlformats.org/drawingml/2006/main"/>
           <a:p xmlns:a="http://schemas.openxmlformats.org/drawingml/2006/main">
             <a:pPr>
-              <a:defRPr sz="1875" b="0">
-                <a:solidFill>
-                  <a:srgbClr val="F8FBFF"/>
-                </a:solidFill>
-                <a:latin typeface="Aptos"/>
-                <a:ea typeface="Aptos"/>
-                <a:cs typeface="Aptos"/>
-              </a:defRPr>
-            </a:pPr>
-            <a:r>
-              <a:rPr sz="1875" b="0">
+              <a:defRPr sz="1800" b="0">
+                <a:solidFill>
+                  <a:srgbClr val="F8FBFF"/>
+                </a:solidFill>
+                <a:latin typeface="Aptos"/>
+                <a:ea typeface="Aptos"/>
+                <a:cs typeface="Aptos"/>
+              </a:defRPr>
+            </a:pPr>
+            <a:r>
+              <a:rPr sz="1800" b="0">
                 <a:solidFill>
                   <a:srgbClr val="F8FBFF"/>
                 </a:solidFill>
@@ -7208,48 +7639,25 @@
           </a:p>
           <a:p xmlns:a="http://schemas.openxmlformats.org/drawingml/2006/main">
             <a:pPr>
-              <a:defRPr sz="1875" b="0">
-                <a:solidFill>
-                  <a:srgbClr val="F8FBFF"/>
-                </a:solidFill>
-                <a:latin typeface="Aptos"/>
-                <a:ea typeface="Aptos"/>
-                <a:cs typeface="Aptos"/>
-              </a:defRPr>
-            </a:pPr>
-            <a:r>
-              <a:rPr sz="1875" b="0">
-                <a:solidFill>
-                  <a:srgbClr val="F8FBFF"/>
-                </a:solidFill>
-                <a:latin typeface="Aptos"/>
-                <a:ea typeface="Aptos"/>
-                <a:cs typeface="Aptos"/>
-              </a:rPr>
-              <a:t>Check the frozen probe</a:t>
-            </a:r>
-          </a:p>
-          <a:p xmlns:a="http://schemas.openxmlformats.org/drawingml/2006/main">
-            <a:pPr>
-              <a:defRPr sz="1875" b="0">
-                <a:solidFill>
-                  <a:srgbClr val="F8FBFF"/>
-                </a:solidFill>
-                <a:latin typeface="Aptos"/>
-                <a:ea typeface="Aptos"/>
-                <a:cs typeface="Aptos"/>
-              </a:defRPr>
-            </a:pPr>
-            <a:r>
-              <a:rPr sz="1875" b="0">
-                <a:solidFill>
-                  <a:srgbClr val="F8FBFF"/>
-                </a:solidFill>
-                <a:latin typeface="Aptos"/>
-                <a:ea typeface="Aptos"/>
-                <a:cs typeface="Aptos"/>
-              </a:rPr>
-              <a:t>and feature checks</a:t>
+              <a:defRPr sz="1800" b="0">
+                <a:solidFill>
+                  <a:srgbClr val="F8FBFF"/>
+                </a:solidFill>
+                <a:latin typeface="Aptos"/>
+                <a:ea typeface="Aptos"/>
+                <a:cs typeface="Aptos"/>
+              </a:defRPr>
+            </a:pPr>
+            <a:r>
+              <a:rPr sz="1800" b="0">
+                <a:solidFill>
+                  <a:srgbClr val="F8FBFF"/>
+                </a:solidFill>
+                <a:latin typeface="Aptos"/>
+                <a:ea typeface="Aptos"/>
+                <a:cs typeface="Aptos"/>
+              </a:rPr>
+              <a:t>Repeat the probe and feature checks</a:t>
             </a:r>
           </a:p>
         </p:txBody>
@@ -7259,7 +7667,7 @@
           <p:cNvPr id="9" name="">
             <a:extLst xmlns:a="http://schemas.openxmlformats.org/drawingml/2006/main">
               <a:ext uri="{FF2B5EF4-FFF2-40B4-BE49-F238E27FC236}">
-                <a16:creationId xmlns:a16="http://schemas.microsoft.com/office/drawing/2014/main" id="{C6B5C1D5-1071-4712-8045-B32B5EE0234F}"/>
+                <a16:creationId xmlns:a16="http://schemas.microsoft.com/office/drawing/2014/main" id="{2DE15B54-57F0-4F69-81C3-A50877D1B879}"/>
               </a:ext>
             </a:extLst>
           </p:cNvPr>
@@ -7290,7 +7698,7 @@
           <p:cNvPr id="10" name="">
             <a:extLst xmlns:a="http://schemas.openxmlformats.org/drawingml/2006/main">
               <a:ext uri="{FF2B5EF4-FFF2-40B4-BE49-F238E27FC236}">
-                <a16:creationId xmlns:a16="http://schemas.microsoft.com/office/drawing/2014/main" id="{938F34FB-20DC-4E4A-873C-56C1AD753AFB}"/>
+                <a16:creationId xmlns:a16="http://schemas.microsoft.com/office/drawing/2014/main" id="{FAD2023B-A2E8-4085-A6F6-4DD845F93284}"/>
               </a:ext>
             </a:extLst>
           </p:cNvPr>
@@ -7321,7 +7729,7 @@
           <p:cNvPr id="11" name="">
             <a:extLst xmlns:a="http://schemas.openxmlformats.org/drawingml/2006/main">
               <a:ext uri="{FF2B5EF4-FFF2-40B4-BE49-F238E27FC236}">
-                <a16:creationId xmlns:a16="http://schemas.microsoft.com/office/drawing/2014/main" id="{C3EE8045-33AD-4CFF-854C-7226D841F479}"/>
+                <a16:creationId xmlns:a16="http://schemas.microsoft.com/office/drawing/2014/main" id="{990682CD-FBCF-46FF-A0F2-D19D5D601F0C}"/>
               </a:ext>
             </a:extLst>
           </p:cNvPr>
@@ -7385,19 +7793,19 @@
           <p:cNvPr id="12" name="">
             <a:extLst xmlns:a="http://schemas.openxmlformats.org/drawingml/2006/main">
               <a:ext uri="{FF2B5EF4-FFF2-40B4-BE49-F238E27FC236}">
-                <a16:creationId xmlns:a16="http://schemas.microsoft.com/office/drawing/2014/main" id="{8D5811B4-2E26-42E2-A2B5-C23E17412BDC}"/>
-              </a:ext>
-            </a:extLst>
-          </p:cNvPr>
-          <p:cNvSpPr>
-            <a:spLocks xmlns:a="http://schemas.openxmlformats.org/drawingml/2006/main" noGrp="1"/>
-          </p:cNvSpPr>
-          <p:nvPr/>
-        </p:nvSpPr>
-        <p:spPr>
-          <a:xfrm xmlns:a="http://schemas.openxmlformats.org/drawingml/2006/main">
-            <a:off x="533400" y="6076950"/>
-            <a:ext cx="7620000" cy="228600"/>
+                <a16:creationId xmlns:a16="http://schemas.microsoft.com/office/drawing/2014/main" id="{CC8D793E-D8D5-4142-8CCC-8F17470B0F25}"/>
+              </a:ext>
+            </a:extLst>
+          </p:cNvPr>
+          <p:cNvSpPr>
+            <a:spLocks xmlns:a="http://schemas.openxmlformats.org/drawingml/2006/main" noGrp="1"/>
+          </p:cNvSpPr>
+          <p:nvPr/>
+        </p:nvSpPr>
+        <p:spPr>
+          <a:xfrm xmlns:a="http://schemas.openxmlformats.org/drawingml/2006/main">
+            <a:off x="533400" y="6029325"/>
+            <a:ext cx="10001250" cy="228600"/>
           </a:xfrm>
           <a:prstGeom xmlns:a="http://schemas.openxmlformats.org/drawingml/2006/main" prst="rect">
             <a:avLst/>
@@ -7416,7 +7824,7 @@
             <a:pPr>
               <a:defRPr sz="1125" b="0">
                 <a:solidFill>
-                  <a:srgbClr val="B9C9DC"/>
+                  <a:srgbClr val="6CE5F5"/>
                 </a:solidFill>
                 <a:latin typeface="Aptos"/>
                 <a:ea typeface="Aptos"/>
@@ -7426,13 +7834,70 @@
             <a:r>
               <a:rPr sz="1125" b="0">
                 <a:solidFill>
-                  <a:srgbClr val="B9C9DC"/>
-                </a:solidFill>
-                <a:latin typeface="Aptos"/>
-                <a:ea typeface="Aptos"/>
-                <a:cs typeface="Aptos"/>
-              </a:rPr>
-              <a:t>Signal Foundry  |  IBM Bob 2.0 Hackathon  |  Public links pending verification</a:t>
+                  <a:srgbClr val="6CE5F5"/>
+                </a:solidFill>
+                <a:latin typeface="Aptos"/>
+                <a:ea typeface="Aptos"/>
+                <a:cs typeface="Aptos"/>
+              </a:rPr>
+              <a:t>Live demo: https://lawliet8886.github.io/MergeWitness/</a:t>
+            </a:r>
+          </a:p>
+        </p:txBody>
+      </p:sp>
+      <p:sp>
+        <p:nvSpPr>
+          <p:cNvPr id="13" name="">
+            <a:extLst xmlns:a="http://schemas.openxmlformats.org/drawingml/2006/main">
+              <a:ext uri="{FF2B5EF4-FFF2-40B4-BE49-F238E27FC236}">
+                <a16:creationId xmlns:a16="http://schemas.microsoft.com/office/drawing/2014/main" id="{CE05AFC5-703C-4518-B0FB-72C12FDE799A}"/>
+              </a:ext>
+            </a:extLst>
+          </p:cNvPr>
+          <p:cNvSpPr>
+            <a:spLocks xmlns:a="http://schemas.openxmlformats.org/drawingml/2006/main" noGrp="1"/>
+          </p:cNvSpPr>
+          <p:nvPr/>
+        </p:nvSpPr>
+        <p:spPr>
+          <a:xfrm xmlns:a="http://schemas.openxmlformats.org/drawingml/2006/main">
+            <a:off x="533400" y="6257925"/>
+            <a:ext cx="10001250" cy="228600"/>
+          </a:xfrm>
+          <a:prstGeom xmlns:a="http://schemas.openxmlformats.org/drawingml/2006/main" prst="rect">
+            <a:avLst/>
+          </a:prstGeom>
+          <a:noFill xmlns:a="http://schemas.openxmlformats.org/drawingml/2006/main"/>
+          <a:ln xmlns:a="http://schemas.openxmlformats.org/drawingml/2006/main" w="0">
+            <a:noFill/>
+          </a:ln>
+        </p:spPr>
+        <p:txBody>
+          <a:bodyPr xmlns:a="http://schemas.openxmlformats.org/drawingml/2006/main">
+            <a:normAutofit fontScale="80000"/>
+          </a:bodyPr>
+          <a:lstStyle xmlns:a="http://schemas.openxmlformats.org/drawingml/2006/main"/>
+          <a:p xmlns:a="http://schemas.openxmlformats.org/drawingml/2006/main">
+            <a:pPr>
+              <a:defRPr sz="1125" b="0">
+                <a:solidFill>
+                  <a:srgbClr val="6CE5F5"/>
+                </a:solidFill>
+                <a:latin typeface="Aptos"/>
+                <a:ea typeface="Aptos"/>
+                <a:cs typeface="Aptos"/>
+              </a:defRPr>
+            </a:pPr>
+            <a:r>
+              <a:rPr sz="1125" b="0">
+                <a:solidFill>
+                  <a:srgbClr val="6CE5F5"/>
+                </a:solidFill>
+                <a:latin typeface="Aptos"/>
+                <a:ea typeface="Aptos"/>
+                <a:cs typeface="Aptos"/>
+              </a:rPr>
+              <a:t>Code and evidence: https://github.com/lawliet8886/MergeWitness</a:t>
             </a:r>
           </a:p>
         </p:txBody>
@@ -7440,7 +7905,7 @@
     </p:spTree>
     <p:extLst>
       <p:ext uri="{BB962C8B-B14F-4D97-AF65-F5344CB8AC3E}">
-        <p14:creationId xmlns:p14="http://schemas.microsoft.com/office/powerpoint/2010/main" val="2011908207"/>
+        <p14:creationId xmlns:p14="http://schemas.microsoft.com/office/powerpoint/2010/main" val="1065438462"/>
       </p:ext>
     </p:extLst>
   </p:cSld>

</xml_diff>